<commit_message>
Week05e demos and Lecture 9 updated
</commit_message>
<xml_diff>
--- a/python/CourseDesign/Week08e/Week8_Lecture15_Characterizing_Random_Signals.pptx
+++ b/python/CourseDesign/Week08e/Week8_Lecture15_Characterizing_Random_Signals.pptx
@@ -4,6 +4,9 @@
   <p:sldMasterIdLst>
     <p:sldMasterId id="2147483648" r:id="rId1"/>
   </p:sldMasterIdLst>
+  <p:notesMasterIdLst>
+    <p:notesMasterId r:id="rId22"/>
+  </p:notesMasterIdLst>
   <p:sldIdLst>
     <p:sldId id="256" r:id="rId2"/>
     <p:sldId id="257" r:id="rId3"/>
@@ -26,9 +29,6 @@
     <p:sldId id="274" r:id="rId20"/>
     <p:sldId id="275" r:id="rId21"/>
   </p:sldIdLst>
-  <p:notesMasterIdLst>
-    <p:notesMasterId r:id="rId22"/>
-  </p:notesMasterIdLst>
   <p:sldSz cx="12192000" cy="6858000"/>
   <p:notesSz cx="6858000" cy="12192000"/>
   <p:defaultTextStyle>
@@ -123,6 +123,11 @@
       </a:defRPr>
     </a:lvl9pPr>
   </p:defaultTextStyle>
+  <p:extLst>
+    <p:ext uri="{EFAFB233-063F-42B5-8137-9DF3F51BA10A}">
+      <p15:sldGuideLst xmlns:p15="http://schemas.microsoft.com/office/powerpoint/2012/main"/>
+    </p:ext>
+  </p:extLst>
 </p:presentation>
 </file>
 
@@ -148,234 +153,10 @@
           <a:chExt cx="0" cy="0"/>
         </a:xfrm>
       </p:grpSpPr>
-      <p:sp>
-        <p:nvSpPr>
-          <p:cNvPr id="2" name="Header Placeholder 1"/>
-          <p:cNvSpPr>
-            <a:spLocks noGrp="1"/>
-          </p:cNvSpPr>
-          <p:nvPr>
-            <p:ph type="hdr" sz="quarter"/>
-          </p:nvPr>
-        </p:nvSpPr>
-        <p:spPr>
-          <a:xfrm>
-            <a:off x="0" y="0"/>
-            <a:ext cx="2971800" cy="458788"/>
-          </a:xfrm>
-          <a:prstGeom prst="rect">
-            <a:avLst/>
-          </a:prstGeom>
-        </p:spPr>
-        <p:txBody>
-          <a:bodyPr vert="horz" lIns="91440" tIns="45720" rIns="91440" bIns="45720" rtlCol="0"/>
-          <a:lstStyle>
-            <a:lvl1pPr algn="l">
-              <a:defRPr sz="1200"/>
-            </a:lvl1pPr>
-          </a:lstStyle>
-          <a:p>
-            <a:endParaRPr lang="en-US"/>
-          </a:p>
-        </p:txBody>
-      </p:sp>
-      <p:sp>
-        <p:nvSpPr>
-          <p:cNvPr id="3" name="Date Placeholder 2"/>
-          <p:cNvSpPr>
-            <a:spLocks noGrp="1"/>
-          </p:cNvSpPr>
-          <p:nvPr>
-            <p:ph type="dt" idx="1"/>
-          </p:nvPr>
-        </p:nvSpPr>
-        <p:spPr>
-          <a:xfrm>
-            <a:off x="3884613" y="0"/>
-            <a:ext cx="2971800" cy="458788"/>
-          </a:xfrm>
-          <a:prstGeom prst="rect">
-            <a:avLst/>
-          </a:prstGeom>
-        </p:spPr>
-        <p:txBody>
-          <a:bodyPr vert="horz" lIns="91440" tIns="45720" rIns="91440" bIns="45720" rtlCol="0"/>
-          <a:lstStyle>
-            <a:lvl1pPr algn="r">
-              <a:defRPr sz="1200"/>
-            </a:lvl1pPr>
-          </a:lstStyle>
-          <a:p>
-            <a:fld id="{5282F153-3F37-0F45-9E97-73ACFA13230C}" type="datetimeFigureOut">
-              <a:rPr lang="en-US"/>
-              <a:t>7/23/19</a:t>
-            </a:fld>
-            <a:endParaRPr lang="en-US"/>
-          </a:p>
-        </p:txBody>
-      </p:sp>
-      <p:sp>
-        <p:nvSpPr>
-          <p:cNvPr id="4" name="Slide Image Placeholder 3"/>
-          <p:cNvSpPr>
-            <a:spLocks noGrp="1" noRot="1" noChangeAspect="1"/>
-          </p:cNvSpPr>
-          <p:nvPr>
-            <p:ph type="sldImg" idx="2"/>
-          </p:nvPr>
-        </p:nvSpPr>
-        <p:spPr>
-          <a:xfrm>
-            <a:off x="685800" y="1143000"/>
-            <a:ext cx="5486400" cy="3086100"/>
-          </a:xfrm>
-          <a:prstGeom prst="rect">
-            <a:avLst/>
-          </a:prstGeom>
-          <a:noFill/>
-          <a:ln w="12700">
-            <a:solidFill>
-              <a:prstClr val="black"/>
-            </a:solidFill>
-          </a:ln>
-        </p:spPr>
-        <p:txBody>
-          <a:bodyPr vert="horz" lIns="91440" tIns="45720" rIns="91440" bIns="45720" rtlCol="0" anchor="ctr"/>
-          <a:lstStyle/>
-          <a:p>
-            <a:endParaRPr lang="en-US"/>
-          </a:p>
-        </p:txBody>
-      </p:sp>
-      <p:sp>
-        <p:nvSpPr>
-          <p:cNvPr id="5" name="Notes Placeholder 4"/>
-          <p:cNvSpPr>
-            <a:spLocks noGrp="1"/>
-          </p:cNvSpPr>
-          <p:nvPr>
-            <p:ph type="body" sz="quarter" idx="3"/>
-          </p:nvPr>
-        </p:nvSpPr>
-        <p:spPr>
-          <a:xfrm>
-            <a:off x="685800" y="4400550"/>
-            <a:ext cx="5486400" cy="3600450"/>
-          </a:xfrm>
-          <a:prstGeom prst="rect">
-            <a:avLst/>
-          </a:prstGeom>
-        </p:spPr>
-        <p:txBody>
-          <a:bodyPr vert="horz" lIns="91440" tIns="45720" rIns="91440" bIns="45720" rtlCol="0"/>
-          <a:lstStyle/>
-          <a:p>
-            <a:pPr lvl="0"/>
-            <a:r>
-              <a:rPr lang="en-US"/>
-              <a:t>Click to edit Master text styles</a:t>
-            </a:r>
-          </a:p>
-          <a:p>
-            <a:pPr lvl="1"/>
-            <a:r>
-              <a:rPr lang="en-US"/>
-              <a:t>Second level</a:t>
-            </a:r>
-          </a:p>
-          <a:p>
-            <a:pPr lvl="2"/>
-            <a:r>
-              <a:rPr lang="en-US"/>
-              <a:t>Third level</a:t>
-            </a:r>
-          </a:p>
-          <a:p>
-            <a:pPr lvl="3"/>
-            <a:r>
-              <a:rPr lang="en-US"/>
-              <a:t>Fourth level</a:t>
-            </a:r>
-          </a:p>
-          <a:p>
-            <a:pPr lvl="4"/>
-            <a:r>
-              <a:rPr lang="en-US"/>
-              <a:t>Fifth level</a:t>
-            </a:r>
-          </a:p>
-        </p:txBody>
-      </p:sp>
-      <p:sp>
-        <p:nvSpPr>
-          <p:cNvPr id="6" name="Footer Placeholder 5"/>
-          <p:cNvSpPr>
-            <a:spLocks noGrp="1"/>
-          </p:cNvSpPr>
-          <p:nvPr>
-            <p:ph type="ftr" sz="quarter" idx="4"/>
-          </p:nvPr>
-        </p:nvSpPr>
-        <p:spPr>
-          <a:xfrm>
-            <a:off x="0" y="8685213"/>
-            <a:ext cx="2971800" cy="458787"/>
-          </a:xfrm>
-          <a:prstGeom prst="rect">
-            <a:avLst/>
-          </a:prstGeom>
-        </p:spPr>
-        <p:txBody>
-          <a:bodyPr vert="horz" lIns="91440" tIns="45720" rIns="91440" bIns="45720" rtlCol="0" anchor="b"/>
-          <a:lstStyle>
-            <a:lvl1pPr algn="l">
-              <a:defRPr sz="1200"/>
-            </a:lvl1pPr>
-          </a:lstStyle>
-          <a:p>
-            <a:endParaRPr lang="en-US"/>
-          </a:p>
-        </p:txBody>
-      </p:sp>
-      <p:sp>
-        <p:nvSpPr>
-          <p:cNvPr id="7" name="Slide Number Placeholder 6"/>
-          <p:cNvSpPr>
-            <a:spLocks noGrp="1"/>
-          </p:cNvSpPr>
-          <p:nvPr>
-            <p:ph type="sldNum" sz="quarter" idx="5"/>
-          </p:nvPr>
-        </p:nvSpPr>
-        <p:spPr>
-          <a:xfrm>
-            <a:off x="3884613" y="8685213"/>
-            <a:ext cx="2971800" cy="458787"/>
-          </a:xfrm>
-          <a:prstGeom prst="rect">
-            <a:avLst/>
-          </a:prstGeom>
-        </p:spPr>
-        <p:txBody>
-          <a:bodyPr vert="horz" lIns="91440" tIns="45720" rIns="91440" bIns="45720" rtlCol="0" anchor="b"/>
-          <a:lstStyle>
-            <a:lvl1pPr algn="r">
-              <a:defRPr sz="1200"/>
-            </a:lvl1pPr>
-          </a:lstStyle>
-          <a:p>
-            <a:fld id="{CE5E9CC1-C706-0F49-92D6-E571CC5EEA8F}" type="slidenum">
-              <a:rPr lang="en-US"/>
-              <a:t>‹#›</a:t>
-            </a:fld>
-            <a:endParaRPr lang="en-US"/>
-          </a:p>
-        </p:txBody>
-      </p:sp>
     </p:spTree>
     <p:extLst>
       <p:ext uri="{BB962C8B-B14F-4D97-AF65-F5344CB8AC3E}">
-        <p14:creationId xmlns:p14="http://schemas.microsoft.com/office/powerpoint/2010/main" val="1024086991"/>
+        <p14:creationId xmlns:p14="http://schemas.microsoft.com/office/powerpoint/2010/main" val="2429870269"/>
       </p:ext>
     </p:extLst>
   </p:cSld>
@@ -523,7 +304,6 @@
               <a:rPr lang="en-US" dirty="0"/>
               <a:t>0:00–0:02. Frame the transition: deterministic DSP asks “what is this signal?” Random-signal DSP asks “what properties are predictable across realizations or time?”</a:t>
             </a:r>
-            <a:endParaRPr lang="en-US" dirty="0"/>
           </a:p>
         </p:txBody>
       </p:sp>
@@ -611,7 +391,6 @@
               <a:rPr lang="en-US" dirty="0"/>
               <a:t>0:35. Move from definitions to things students can estimate and use.</a:t>
             </a:r>
-            <a:endParaRPr lang="en-US" dirty="0"/>
           </a:p>
         </p:txBody>
       </p:sp>
@@ -699,7 +478,6 @@
               <a:rPr lang="en-US" dirty="0"/>
               <a:t>0:35–0:42. Connect rxx[0] to average signal power.</a:t>
             </a:r>
-            <a:endParaRPr lang="en-US" dirty="0"/>
           </a:p>
         </p:txBody>
       </p:sp>
@@ -787,7 +565,6 @@
               <a:rPr lang="en-US" dirty="0"/>
               <a:t>0:42–0:49. Explain that “uncorrelated at nonzero lags” is a second-order statement; it does not automatically imply independence unless special distributions such as jointly Gaussian apply.</a:t>
             </a:r>
-            <a:endParaRPr lang="en-US" dirty="0"/>
           </a:p>
         </p:txBody>
       </p:sp>
@@ -875,7 +652,6 @@
               <a:rPr lang="en-US" dirty="0"/>
               <a:t>0:49–0:55. This convention choice matters in Lecture 16. The user outline had a reversed h formula inconsistent with this definition; the next lecture explicitly reconciles the two conventions.</a:t>
             </a:r>
-            <a:endParaRPr lang="en-US" dirty="0"/>
           </a:p>
         </p:txBody>
       </p:sp>
@@ -963,7 +739,6 @@
               <a:rPr lang="en-US" dirty="0"/>
               <a:t>0:55–1:00. Derive PSD property from E{|a^H x|^2} ≥ 0. This connects directly to PCA/covariance matrices later.</a:t>
             </a:r>
-            <a:endParaRPr lang="en-US" dirty="0"/>
           </a:p>
         </p:txBody>
       </p:sp>
@@ -1051,7 +826,6 @@
               <a:rPr lang="en-US" dirty="0"/>
               <a:t>1:00–1:03. This is a high-value bridge to linear algebra and ML covariance matrices.</a:t>
             </a:r>
-            <a:endParaRPr lang="en-US" dirty="0"/>
           </a:p>
         </p:txBody>
       </p:sp>
@@ -1139,7 +913,6 @@
               <a:rPr lang="en-US" dirty="0"/>
               <a:t>1:03. Ask students why a classifier might fail when the same waveform arrives at different offsets.</a:t>
             </a:r>
-            <a:endParaRPr lang="en-US" dirty="0"/>
           </a:p>
         </p:txBody>
       </p:sp>
@@ -1227,7 +1000,6 @@
               <a:rPr lang="en-US" dirty="0"/>
               <a:t>1:03–1:11. Example: machinery impulse appears at variable trigger delay. Aligning before extracting RMS, spectral, or learned features reduces irrelevant timing variability.</a:t>
             </a:r>
-            <a:endParaRPr lang="en-US" dirty="0"/>
           </a:p>
         </p:txBody>
       </p:sp>
@@ -1315,7 +1087,6 @@
               <a:rPr lang="en-US" dirty="0"/>
               <a:t>1:11–1:14. Use this as a mini-lab or exit prediction.</a:t>
             </a:r>
-            <a:endParaRPr lang="en-US" dirty="0"/>
           </a:p>
         </p:txBody>
       </p:sp>
@@ -1403,7 +1174,6 @@
               <a:rPr lang="en-US" dirty="0"/>
               <a:t>1:14–1:15. Collect one-sentence responses.</a:t>
             </a:r>
-            <a:endParaRPr lang="en-US" dirty="0"/>
           </a:p>
         </p:txBody>
       </p:sp>
@@ -1491,7 +1261,6 @@
               <a:rPr lang="en-US" dirty="0"/>
               <a:t>Core question: What can we estimate reliably from one finite realization, and under what assumptions does that estimate represent the process?</a:t>
             </a:r>
-            <a:endParaRPr lang="en-US" dirty="0"/>
           </a:p>
         </p:txBody>
       </p:sp>
@@ -1575,10 +1344,6 @@
           <a:bodyPr/>
           <a:lstStyle/>
           <a:p>
-            <a:r>
-              <a:rPr lang="en-US" dirty="0"/>
-              <a:t/>
-            </a:r>
             <a:endParaRPr lang="en-US" dirty="0"/>
           </a:p>
         </p:txBody>
@@ -1667,7 +1432,6 @@
               <a:rPr lang="en-US" dirty="0"/>
               <a:t>0:02–0:03. Keep notation light: X[n] is a random variable at each n; x[n] is one realized sequence.</a:t>
             </a:r>
-            <a:endParaRPr lang="en-US" dirty="0"/>
           </a:p>
         </p:txBody>
       </p:sp>
@@ -1755,7 +1519,6 @@
               <a:rPr lang="en-US" dirty="0"/>
               <a:t>0:03–0:10. Example: microphone noise recorded six times under nominally identical conditions. Each recording is a realization. The process is the probabilistic source model.</a:t>
             </a:r>
-            <a:endParaRPr lang="en-US" dirty="0"/>
           </a:p>
         </p:txBody>
       </p:sp>
@@ -1843,7 +1606,6 @@
               <a:rPr lang="en-US" dirty="0"/>
               <a:t>0:10–0:15. Introduce ergodicity only as a preview. This distinction prevents a common misconception.</a:t>
             </a:r>
-            <a:endParaRPr lang="en-US" dirty="0"/>
           </a:p>
         </p:txBody>
       </p:sp>
@@ -1931,7 +1693,6 @@
               <a:rPr lang="en-US" dirty="0"/>
               <a:t>0:15. Motivate: without some stability assumption, every n could need a different model.</a:t>
             </a:r>
-            <a:endParaRPr lang="en-US" dirty="0"/>
           </a:p>
         </p:txBody>
       </p:sp>
@@ -2019,7 +1780,6 @@
               <a:rPr lang="en-US" dirty="0"/>
               <a:t>0:15–0:22. “≍” means equal in distribution. Avoid spending too long on joint-CDF notation unless the cohort is mathematically ready.</a:t>
             </a:r>
-            <a:endParaRPr lang="en-US" dirty="0"/>
           </a:p>
         </p:txBody>
       </p:sp>
@@ -2107,7 +1867,6 @@
               <a:rPr lang="en-US" dirty="0"/>
               <a:t>0:22–0:30. Stress that WSS is not “signal looks flat.” It is a statement about first and second moments.</a:t>
             </a:r>
-            <a:endParaRPr lang="en-US" dirty="0"/>
           </a:p>
         </p:txBody>
       </p:sp>
@@ -2195,7 +1954,6 @@
               <a:rPr lang="en-US" dirty="0"/>
               <a:t>0:30–0:35. Let students answer in pairs. Good answer must mention variance / autocorrelation at lag zero, not just “it changes.”</a:t>
             </a:r>
-            <a:endParaRPr lang="en-US" dirty="0"/>
           </a:p>
         </p:txBody>
       </p:sp>
@@ -2273,6 +2031,7 @@
         <a:solidFill>
           <a:srgbClr val="FFFFFF"/>
         </a:solidFill>
+        <a:effectLst/>
       </p:bgPr>
     </p:bg>
     <p:spTree>
@@ -2335,7 +2094,7 @@
           <a:bodyPr wrap="square" lIns="0" tIns="0" rIns="0" bIns="0" rtlCol="0" anchor="ctr"/>
           <a:lstStyle/>
           <a:p>
-            <a:pPr indent="0" marL="0">
+            <a:pPr marL="0" indent="0">
               <a:buNone/>
             </a:pPr>
             <a:r>
@@ -2374,7 +2133,7 @@
           <a:bodyPr wrap="square" lIns="0" tIns="0" rIns="0" bIns="0" rtlCol="0" anchor="ctr"/>
           <a:lstStyle/>
           <a:p>
-            <a:pPr algn="r" indent="0" marL="0">
+            <a:pPr marL="0" indent="0" algn="r">
               <a:buNone/>
             </a:pPr>
             <a:r>
@@ -2435,7 +2194,7 @@
           </a:prstGeom>
           <a:extLst>
             <a:ext uri="{C572A759-6A51-4108-AA02-DFA0A04FC94B}">
-              <ma14:wrappingTextBoxFlag xmlns:ma14="http://schemas.microsoft.com/office/mac/drawingml/2011/main" val="0"/>
+              <ma14:wrappingTextBoxFlag xmlns:ma14="http://schemas.microsoft.com/office/mac/drawingml/2011/main" xmlns="" val="0"/>
             </a:ext>
           </a:extLst>
         </p:spPr>
@@ -2456,8 +2215,8 @@
           <a:p>
             <a:pPr algn="r"/>
             <a:fld id="{F7021451-1387-4CA6-816F-3879F97B5CBC}" type="slidenum">
-              <a:rPr b="0" lang="en-US"/>
-              <a:t>1002</a:t>
+              <a:rPr lang="en-US" b="0"/>
+              <a:t>‹#›</a:t>
             </a:fld>
             <a:endParaRPr lang="en-US"/>
           </a:p>
@@ -2474,6 +2233,11 @@
 <file path=ppt/slideMasters/slideMaster1.xml><?xml version="1.0" encoding="utf-8"?>
 <p:sldMaster xmlns:a="http://schemas.openxmlformats.org/drawingml/2006/main" xmlns:r="http://schemas.openxmlformats.org/officeDocument/2006/relationships" xmlns:p="http://schemas.openxmlformats.org/presentationml/2006/main">
   <p:cSld>
+    <p:bg>
+      <p:bgRef idx="1001">
+        <a:schemeClr val="bg1"/>
+      </p:bgRef>
+    </p:bg>
     <p:spTree>
       <p:nvGrpSpPr>
         <p:cNvPr id="1" name=""/>
@@ -2508,7 +2272,7 @@
           </a:prstGeom>
           <a:extLst>
             <a:ext uri="{C572A759-6A51-4108-AA02-DFA0A04FC94B}">
-              <ma14:wrappingTextBoxFlag xmlns:ma14="http://schemas.microsoft.com/office/mac/drawingml/2011/main" val="0"/>
+              <ma14:wrappingTextBoxFlag xmlns:ma14="http://schemas.microsoft.com/office/mac/drawingml/2011/main" xmlns="" val="0"/>
             </a:ext>
           </a:extLst>
         </p:spPr>
@@ -2529,8 +2293,8 @@
           <a:p>
             <a:pPr algn="r"/>
             <a:fld id="{F7021451-1387-4CA6-816F-3879F97B5CBC}" type="slidenum">
-              <a:rPr b="0" lang="en-US"/>
-              <a:t>null</a:t>
+              <a:rPr lang="en-US" b="0"/>
+              <a:t>‹#›</a:t>
             </a:fld>
             <a:endParaRPr lang="en-US"/>
           </a:p>
@@ -2805,6 +2569,7 @@
         <a:solidFill>
           <a:srgbClr val="17324D"/>
         </a:solidFill>
+        <a:effectLst/>
       </p:bgPr>
     </p:bg>
     <p:spTree>
@@ -2845,46 +2610,122 @@
             <a:prstDash val="solid"/>
           </a:ln>
         </p:spPr>
-      </p:sp>
-      <p:sp>
-        <p:nvSpPr>
-          <p:cNvPr id="3" name="Text 1"/>
-          <p:cNvSpPr/>
-          <p:nvPr/>
-        </p:nvSpPr>
-        <p:spPr>
-          <a:xfrm>
-            <a:off x="713232" y="713232"/>
-            <a:ext cx="1920240" cy="274320"/>
-          </a:xfrm>
-          <a:prstGeom prst="rect">
-            <a:avLst/>
-          </a:prstGeom>
-          <a:noFill/>
-          <a:ln/>
-        </p:spPr>
-        <p:txBody>
-          <a:bodyPr wrap="square" lIns="0" tIns="0" rIns="0" bIns="0" rtlCol="0" anchor="ctr"/>
-          <a:lstStyle/>
-          <a:p>
-            <a:pPr indent="0" marL="0">
-              <a:buNone/>
-            </a:pPr>
-            <a:r>
-              <a:rPr lang="en-US" sz="1200" b="1" dirty="0">
-                <a:solidFill>
-                  <a:srgbClr val="8EDCE5"/>
-                </a:solidFill>
-                <a:latin typeface="Aptos" pitchFamily="34" charset="0"/>
-                <a:ea typeface="Aptos" pitchFamily="34" charset="-122"/>
-                <a:cs typeface="Aptos" pitchFamily="34" charset="-120"/>
-              </a:rPr>
-              <a:t>LECTURE 15</a:t>
-            </a:r>
-            <a:endParaRPr lang="en-US" sz="1200" dirty="0"/>
-          </a:p>
-        </p:txBody>
-      </p:sp>
+        <p:txBody>
+          <a:bodyPr/>
+          <a:lstStyle/>
+          <a:p>
+            <a:endParaRPr lang="en-US"/>
+          </a:p>
+        </p:txBody>
+      </p:sp>
+      <mc:AlternateContent xmlns:mc="http://schemas.openxmlformats.org/markup-compatibility/2006">
+        <mc:Choice xmlns:a14="http://schemas.microsoft.com/office/drawing/2010/main" Requires="a14">
+          <p:sp>
+            <p:nvSpPr>
+              <p:cNvPr id="3" name="Text 1"/>
+              <p:cNvSpPr/>
+              <p:nvPr/>
+            </p:nvSpPr>
+            <p:spPr>
+              <a:xfrm>
+                <a:off x="713232" y="713232"/>
+                <a:ext cx="1920240" cy="274320"/>
+              </a:xfrm>
+              <a:prstGeom prst="rect">
+                <a:avLst/>
+              </a:prstGeom>
+              <a:noFill/>
+              <a:ln/>
+            </p:spPr>
+            <p:txBody>
+              <a:bodyPr wrap="square" lIns="0" tIns="0" rIns="0" bIns="0" rtlCol="0" anchor="ctr"/>
+              <a:lstStyle/>
+              <a:p>
+                <a:pPr marL="0" indent="0">
+                  <a:buNone/>
+                </a:pPr>
+                <a:r>
+                  <a:rPr lang="en-US" sz="1200" b="1" dirty="0">
+                    <a:solidFill>
+                      <a:srgbClr val="8EDCE5"/>
+                    </a:solidFill>
+                    <a:latin typeface="Aptos" pitchFamily="34" charset="0"/>
+                    <a:ea typeface="Aptos" pitchFamily="34" charset="-122"/>
+                    <a:cs typeface="Aptos" pitchFamily="34" charset="-120"/>
+                  </a:rPr>
+                  <a:t>WEEK 8 </a:t>
+                </a:r>
+                <a14:m>
+                  <m:oMath xmlns:m="http://schemas.openxmlformats.org/officeDocument/2006/math">
+                    <m:r>
+                      <a:rPr lang="en-US" sz="1200" b="1" i="1" smtClean="0">
+                        <a:solidFill>
+                          <a:srgbClr val="8EDCE5"/>
+                        </a:solidFill>
+                        <a:latin typeface="Cambria Math" panose="02040503050406030204" pitchFamily="18" charset="0"/>
+                        <a:ea typeface="Aptos" pitchFamily="34" charset="-122"/>
+                        <a:cs typeface="Aptos" pitchFamily="34" charset="-120"/>
+                      </a:rPr>
+                      <m:t>●</m:t>
+                    </m:r>
+                  </m:oMath>
+                </a14:m>
+                <a:r>
+                  <a:rPr lang="en-US" sz="1200" b="1" dirty="0">
+                    <a:solidFill>
+                      <a:srgbClr val="8EDCE5"/>
+                    </a:solidFill>
+                    <a:latin typeface="Aptos" pitchFamily="34" charset="0"/>
+                    <a:ea typeface="Aptos" pitchFamily="34" charset="-122"/>
+                    <a:cs typeface="Aptos" pitchFamily="34" charset="-120"/>
+                  </a:rPr>
+                  <a:t> LECTURE 15</a:t>
+                </a:r>
+                <a:endParaRPr lang="en-US" sz="1200" dirty="0"/>
+              </a:p>
+            </p:txBody>
+          </p:sp>
+        </mc:Choice>
+        <mc:Fallback>
+          <p:sp>
+            <p:nvSpPr>
+              <p:cNvPr id="3" name="Text 1"/>
+              <p:cNvSpPr>
+                <a:spLocks noRot="1" noChangeAspect="1" noMove="1" noResize="1" noEditPoints="1" noAdjustHandles="1" noChangeArrowheads="1" noChangeShapeType="1" noTextEdit="1"/>
+              </p:cNvSpPr>
+              <p:nvPr/>
+            </p:nvSpPr>
+            <p:spPr>
+              <a:xfrm>
+                <a:off x="713232" y="713232"/>
+                <a:ext cx="1920240" cy="274320"/>
+              </a:xfrm>
+              <a:prstGeom prst="rect">
+                <a:avLst/>
+              </a:prstGeom>
+              <a:blipFill>
+                <a:blip r:embed="rId3"/>
+                <a:stretch>
+                  <a:fillRect l="-4762" b="-17778"/>
+                </a:stretch>
+              </a:blipFill>
+              <a:ln/>
+            </p:spPr>
+            <p:txBody>
+              <a:bodyPr/>
+              <a:lstStyle/>
+              <a:p>
+                <a:r>
+                  <a:rPr lang="en-US">
+                    <a:noFill/>
+                  </a:rPr>
+                  <a:t> </a:t>
+                </a:r>
+              </a:p>
+            </p:txBody>
+          </p:sp>
+        </mc:Fallback>
+      </mc:AlternateContent>
       <p:sp>
         <p:nvSpPr>
           <p:cNvPr id="4" name="Text 2"/>
@@ -2908,7 +2749,7 @@
           </a:bodyPr>
           <a:lstStyle/>
           <a:p>
-            <a:pPr indent="0" marL="0">
+            <a:pPr marL="0" indent="0">
               <a:buNone/>
             </a:pPr>
             <a:r>
@@ -2947,7 +2788,7 @@
           <a:bodyPr wrap="square" lIns="0" tIns="0" rIns="0" bIns="0" rtlCol="0" anchor="ctr"/>
           <a:lstStyle/>
           <a:p>
-            <a:pPr indent="0" marL="0">
+            <a:pPr marL="0" indent="0">
               <a:buNone/>
             </a:pPr>
             <a:r>
@@ -2989,6 +2830,13 @@
             <a:prstDash val="solid"/>
           </a:ln>
         </p:spPr>
+        <p:txBody>
+          <a:bodyPr/>
+          <a:lstStyle/>
+          <a:p>
+            <a:endParaRPr lang="en-US"/>
+          </a:p>
+        </p:txBody>
       </p:sp>
       <p:sp>
         <p:nvSpPr>
@@ -3013,7 +2861,7 @@
           </a:bodyPr>
           <a:lstStyle/>
           <a:p>
-            <a:pPr algn="ctr" indent="0" marL="0">
+            <a:pPr marL="0" indent="0" algn="ctr">
               <a:buNone/>
             </a:pPr>
             <a:r>
@@ -3055,6 +2903,13 @@
             <a:prstDash val="solid"/>
           </a:ln>
         </p:spPr>
+        <p:txBody>
+          <a:bodyPr/>
+          <a:lstStyle/>
+          <a:p>
+            <a:endParaRPr lang="en-US"/>
+          </a:p>
+        </p:txBody>
       </p:sp>
       <p:sp>
         <p:nvSpPr>
@@ -3079,7 +2934,7 @@
           </a:bodyPr>
           <a:lstStyle/>
           <a:p>
-            <a:pPr algn="ctr" indent="0" marL="0">
+            <a:pPr marL="0" indent="0" algn="ctr">
               <a:buNone/>
             </a:pPr>
             <a:r>
@@ -3118,7 +2973,7 @@
           <a:bodyPr wrap="square" lIns="0" tIns="0" rIns="0" bIns="0" rtlCol="0" anchor="ctr"/>
           <a:lstStyle/>
           <a:p>
-            <a:pPr indent="0" marL="0">
+            <a:pPr marL="0" indent="0">
               <a:buNone/>
             </a:pPr>
             <a:r>
@@ -3152,6 +3007,7 @@
         <a:solidFill>
           <a:srgbClr val="17324D"/>
         </a:solidFill>
+        <a:effectLst/>
       </p:bgPr>
     </p:bg>
     <p:spTree>
@@ -3189,7 +3045,7 @@
           <a:bodyPr wrap="square" lIns="0" tIns="0" rIns="0" bIns="0" rtlCol="0" anchor="ctr"/>
           <a:lstStyle/>
           <a:p>
-            <a:pPr indent="0" marL="0">
+            <a:pPr marL="0" indent="0">
               <a:buNone/>
             </a:pPr>
             <a:r>
@@ -3228,7 +3084,7 @@
           <a:bodyPr wrap="square" lIns="0" tIns="0" rIns="0" bIns="0" rtlCol="0" anchor="ctr"/>
           <a:lstStyle/>
           <a:p>
-            <a:pPr indent="0" marL="0">
+            <a:pPr marL="0" indent="0">
               <a:buNone/>
             </a:pPr>
             <a:r>
@@ -3267,7 +3123,7 @@
           <a:bodyPr wrap="square" lIns="0" tIns="0" rIns="0" bIns="0" rtlCol="0" anchor="ctr"/>
           <a:lstStyle/>
           <a:p>
-            <a:pPr indent="0" marL="0">
+            <a:pPr marL="0" indent="0">
               <a:buNone/>
             </a:pPr>
             <a:r>
@@ -3305,7 +3161,7 @@
           </a:prstGeom>
           <a:extLst>
             <a:ext uri="{C572A759-6A51-4108-AA02-DFA0A04FC94B}">
-              <ma14:wrappingTextBoxFlag xmlns:ma14="http://schemas.microsoft.com/office/mac/drawingml/2011/main" val="0"/>
+              <ma14:wrappingTextBoxFlag xmlns:ma14="http://schemas.microsoft.com/office/mac/drawingml/2011/main" xmlns="" val="0"/>
             </a:ext>
           </a:extLst>
         </p:spPr>
@@ -3326,7 +3182,7 @@
           <a:p>
             <a:pPr algn="r"/>
             <a:fld id="{F7021451-1387-4CA6-816F-3879F97B5CBC}" type="slidenum">
-              <a:rPr b="0" lang="en-US"/>
+              <a:rPr lang="en-US" b="0"/>
               <a:t>10</a:t>
             </a:fld>
             <a:endParaRPr lang="en-US"/>
@@ -3379,7 +3235,7 @@
           <a:bodyPr wrap="square" lIns="0" tIns="0" rIns="0" bIns="0" rtlCol="0" anchor="ctr"/>
           <a:lstStyle/>
           <a:p>
-            <a:pPr indent="0" marL="0">
+            <a:pPr marL="0" indent="0">
               <a:buNone/>
             </a:pPr>
             <a:r>
@@ -3418,7 +3274,7 @@
           <a:bodyPr wrap="square" lIns="0" tIns="0" rIns="0" bIns="0" rtlCol="0" anchor="ctr"/>
           <a:lstStyle/>
           <a:p>
-            <a:pPr indent="0" marL="0">
+            <a:pPr marL="0" indent="0">
               <a:buNone/>
             </a:pPr>
             <a:r>
@@ -3460,6 +3316,13 @@
             <a:prstDash val="solid"/>
           </a:ln>
         </p:spPr>
+        <p:txBody>
+          <a:bodyPr/>
+          <a:lstStyle/>
+          <a:p>
+            <a:endParaRPr lang="en-US"/>
+          </a:p>
+        </p:txBody>
       </p:sp>
       <p:sp>
         <p:nvSpPr>
@@ -3484,7 +3347,7 @@
           </a:bodyPr>
           <a:lstStyle/>
           <a:p>
-            <a:pPr algn="ctr" indent="0" marL="0">
+            <a:pPr marL="0" indent="0" algn="ctr">
               <a:buNone/>
             </a:pPr>
             <a:r>
@@ -3526,6 +3389,13 @@
             <a:prstDash val="solid"/>
           </a:ln>
         </p:spPr>
+        <p:txBody>
+          <a:bodyPr/>
+          <a:lstStyle/>
+          <a:p>
+            <a:endParaRPr lang="en-US"/>
+          </a:p>
+        </p:txBody>
       </p:sp>
       <p:sp>
         <p:nvSpPr>
@@ -3550,7 +3420,7 @@
           </a:bodyPr>
           <a:lstStyle/>
           <a:p>
-            <a:pPr algn="ctr" indent="0" marL="0">
+            <a:pPr marL="0" indent="0" algn="ctr">
               <a:buNone/>
             </a:pPr>
             <a:r>
@@ -3592,6 +3462,13 @@
             <a:prstDash val="solid"/>
           </a:ln>
         </p:spPr>
+        <p:txBody>
+          <a:bodyPr/>
+          <a:lstStyle/>
+          <a:p>
+            <a:endParaRPr lang="en-US"/>
+          </a:p>
+        </p:txBody>
       </p:sp>
       <p:sp>
         <p:nvSpPr>
@@ -3616,7 +3493,7 @@
           </a:bodyPr>
           <a:lstStyle/>
           <a:p>
-            <a:pPr algn="ctr" indent="0" marL="0">
+            <a:pPr marL="0" indent="0" algn="ctr">
               <a:buNone/>
             </a:pPr>
             <a:r>
@@ -3660,6 +3537,13 @@
             <a:prstDash val="solid"/>
           </a:ln>
         </p:spPr>
+        <p:txBody>
+          <a:bodyPr/>
+          <a:lstStyle/>
+          <a:p>
+            <a:endParaRPr lang="en-US"/>
+          </a:p>
+        </p:txBody>
       </p:sp>
       <p:sp>
         <p:nvSpPr>
@@ -3685,6 +3569,13 @@
             <a:prstDash val="solid"/>
           </a:ln>
         </p:spPr>
+        <p:txBody>
+          <a:bodyPr/>
+          <a:lstStyle/>
+          <a:p>
+            <a:endParaRPr lang="en-US"/>
+          </a:p>
+        </p:txBody>
       </p:sp>
       <p:sp>
         <p:nvSpPr>
@@ -3707,7 +3598,7 @@
           <a:bodyPr wrap="square" lIns="0" tIns="0" rIns="0" bIns="0" rtlCol="0" anchor="ctr"/>
           <a:lstStyle/>
           <a:p>
-            <a:pPr indent="0" marL="0">
+            <a:pPr marL="0" indent="0">
               <a:buNone/>
             </a:pPr>
             <a:r>
@@ -3748,7 +3639,7 @@
           </a:bodyPr>
           <a:lstStyle/>
           <a:p>
-            <a:pPr indent="0" marL="0">
+            <a:pPr marL="0" indent="0">
               <a:buNone/>
             </a:pPr>
             <a:r>
@@ -3792,6 +3683,13 @@
             <a:prstDash val="solid"/>
           </a:ln>
         </p:spPr>
+        <p:txBody>
+          <a:bodyPr/>
+          <a:lstStyle/>
+          <a:p>
+            <a:endParaRPr lang="en-US"/>
+          </a:p>
+        </p:txBody>
       </p:sp>
       <p:sp>
         <p:nvSpPr>
@@ -3817,6 +3715,13 @@
             <a:prstDash val="solid"/>
           </a:ln>
         </p:spPr>
+        <p:txBody>
+          <a:bodyPr/>
+          <a:lstStyle/>
+          <a:p>
+            <a:endParaRPr lang="en-US"/>
+          </a:p>
+        </p:txBody>
       </p:sp>
       <p:sp>
         <p:nvSpPr>
@@ -3839,7 +3744,7 @@
           <a:bodyPr wrap="square" lIns="0" tIns="0" rIns="0" bIns="0" rtlCol="0" anchor="ctr"/>
           <a:lstStyle/>
           <a:p>
-            <a:pPr indent="0" marL="0">
+            <a:pPr marL="0" indent="0">
               <a:buNone/>
             </a:pPr>
             <a:r>
@@ -3880,7 +3785,7 @@
           </a:bodyPr>
           <a:lstStyle/>
           <a:p>
-            <a:pPr indent="0" marL="0">
+            <a:pPr marL="0" indent="0">
               <a:buNone/>
             </a:pPr>
             <a:r>
@@ -3924,6 +3829,13 @@
             <a:prstDash val="solid"/>
           </a:ln>
         </p:spPr>
+        <p:txBody>
+          <a:bodyPr/>
+          <a:lstStyle/>
+          <a:p>
+            <a:endParaRPr lang="en-US"/>
+          </a:p>
+        </p:txBody>
       </p:sp>
       <p:sp>
         <p:nvSpPr>
@@ -3949,6 +3861,13 @@
             <a:prstDash val="solid"/>
           </a:ln>
         </p:spPr>
+        <p:txBody>
+          <a:bodyPr/>
+          <a:lstStyle/>
+          <a:p>
+            <a:endParaRPr lang="en-US"/>
+          </a:p>
+        </p:txBody>
       </p:sp>
       <p:sp>
         <p:nvSpPr>
@@ -3971,7 +3890,7 @@
           <a:bodyPr wrap="square" lIns="0" tIns="0" rIns="0" bIns="0" rtlCol="0" anchor="ctr"/>
           <a:lstStyle/>
           <a:p>
-            <a:pPr indent="0" marL="0">
+            <a:pPr marL="0" indent="0">
               <a:buNone/>
             </a:pPr>
             <a:r>
@@ -4012,7 +3931,7 @@
           </a:bodyPr>
           <a:lstStyle/>
           <a:p>
-            <a:pPr indent="0" marL="0">
+            <a:pPr marL="0" indent="0">
               <a:buNone/>
             </a:pPr>
             <a:r>
@@ -4050,7 +3969,7 @@
           </a:prstGeom>
           <a:extLst>
             <a:ext uri="{C572A759-6A51-4108-AA02-DFA0A04FC94B}">
-              <ma14:wrappingTextBoxFlag xmlns:ma14="http://schemas.microsoft.com/office/mac/drawingml/2011/main" val="0"/>
+              <ma14:wrappingTextBoxFlag xmlns:ma14="http://schemas.microsoft.com/office/mac/drawingml/2011/main" xmlns="" val="0"/>
             </a:ext>
           </a:extLst>
         </p:spPr>
@@ -4071,7 +3990,7 @@
           <a:p>
             <a:pPr algn="r"/>
             <a:fld id="{F7021451-1387-4CA6-816F-3879F97B5CBC}" type="slidenum">
-              <a:rPr b="0" lang="en-US"/>
+              <a:rPr lang="en-US" b="0"/>
               <a:t>11</a:t>
             </a:fld>
             <a:endParaRPr lang="en-US"/>
@@ -4124,7 +4043,7 @@
           <a:bodyPr wrap="square" lIns="0" tIns="0" rIns="0" bIns="0" rtlCol="0" anchor="ctr"/>
           <a:lstStyle/>
           <a:p>
-            <a:pPr indent="0" marL="0">
+            <a:pPr marL="0" indent="0">
               <a:buNone/>
             </a:pPr>
             <a:r>
@@ -4163,7 +4082,7 @@
           <a:bodyPr wrap="square" lIns="0" tIns="0" rIns="0" bIns="0" rtlCol="0" anchor="ctr"/>
           <a:lstStyle/>
           <a:p>
-            <a:pPr indent="0" marL="0">
+            <a:pPr marL="0" indent="0">
               <a:buNone/>
             </a:pPr>
             <a:r>
@@ -4205,6 +4124,13 @@
             <a:prstDash val="solid"/>
           </a:ln>
         </p:spPr>
+        <p:txBody>
+          <a:bodyPr/>
+          <a:lstStyle/>
+          <a:p>
+            <a:endParaRPr lang="en-US"/>
+          </a:p>
+        </p:txBody>
       </p:sp>
       <p:sp>
         <p:nvSpPr>
@@ -4229,7 +4155,7 @@
           </a:bodyPr>
           <a:lstStyle/>
           <a:p>
-            <a:pPr algn="ctr" indent="0" marL="0">
+            <a:pPr marL="0" indent="0" algn="ctr">
               <a:buNone/>
             </a:pPr>
             <a:r>
@@ -4249,14 +4175,14 @@
       </p:sp>
       <p:pic>
         <p:nvPicPr>
-          <p:cNvPr id="6" name="Image 0" descr="/mnt/data/week8_random_signals/assets/acf_white_ar1.png">    </p:cNvPr>
+          <p:cNvPr id="6" name="Image 0" descr="/mnt/data/week8_random_signals/assets/acf_white_ar1.png"/>
           <p:cNvPicPr>
             <a:picLocks noChangeAspect="1"/>
           </p:cNvPicPr>
           <p:nvPr/>
         </p:nvPicPr>
         <p:blipFill>
-          <a:blip r:embed="rId1"/>
+          <a:blip r:embed="rId3"/>
           <a:stretch>
             <a:fillRect/>
           </a:stretch>
@@ -4387,7 +4313,7 @@
           </a:prstGeom>
           <a:extLst>
             <a:ext uri="{C572A759-6A51-4108-AA02-DFA0A04FC94B}">
-              <ma14:wrappingTextBoxFlag xmlns:ma14="http://schemas.microsoft.com/office/mac/drawingml/2011/main" val="0"/>
+              <ma14:wrappingTextBoxFlag xmlns:ma14="http://schemas.microsoft.com/office/mac/drawingml/2011/main" xmlns="" val="0"/>
             </a:ext>
           </a:extLst>
         </p:spPr>
@@ -4408,7 +4334,7 @@
           <a:p>
             <a:pPr algn="r"/>
             <a:fld id="{F7021451-1387-4CA6-816F-3879F97B5CBC}" type="slidenum">
-              <a:rPr b="0" lang="en-US"/>
+              <a:rPr lang="en-US" b="0"/>
               <a:t>12</a:t>
             </a:fld>
             <a:endParaRPr lang="en-US"/>
@@ -4461,7 +4387,7 @@
           <a:bodyPr wrap="square" lIns="0" tIns="0" rIns="0" bIns="0" rtlCol="0" anchor="ctr"/>
           <a:lstStyle/>
           <a:p>
-            <a:pPr indent="0" marL="0">
+            <a:pPr marL="0" indent="0">
               <a:buNone/>
             </a:pPr>
             <a:r>
@@ -4500,7 +4426,7 @@
           <a:bodyPr wrap="square" lIns="0" tIns="0" rIns="0" bIns="0" rtlCol="0" anchor="ctr"/>
           <a:lstStyle/>
           <a:p>
-            <a:pPr indent="0" marL="0">
+            <a:pPr marL="0" indent="0">
               <a:buNone/>
             </a:pPr>
             <a:r>
@@ -4542,6 +4468,13 @@
             <a:prstDash val="solid"/>
           </a:ln>
         </p:spPr>
+        <p:txBody>
+          <a:bodyPr/>
+          <a:lstStyle/>
+          <a:p>
+            <a:endParaRPr lang="en-US"/>
+          </a:p>
+        </p:txBody>
       </p:sp>
       <p:sp>
         <p:nvSpPr>
@@ -4566,7 +4499,7 @@
           </a:bodyPr>
           <a:lstStyle/>
           <a:p>
-            <a:pPr algn="ctr" indent="0" marL="0">
+            <a:pPr marL="0" indent="0" algn="ctr">
               <a:buNone/>
             </a:pPr>
             <a:r>
@@ -4586,14 +4519,14 @@
       </p:sp>
       <p:pic>
         <p:nvPicPr>
-          <p:cNvPr id="6" name="Image 0" descr="/mnt/data/week8_random_signals/assets/template_matching.png">    </p:cNvPr>
+          <p:cNvPr id="6" name="Image 0" descr="/mnt/data/week8_random_signals/assets/template_matching.png"/>
           <p:cNvPicPr>
             <a:picLocks noChangeAspect="1"/>
           </p:cNvPicPr>
           <p:nvPr/>
         </p:nvPicPr>
         <p:blipFill>
-          <a:blip r:embed="rId1"/>
+          <a:blip r:embed="rId3"/>
           <a:stretch>
             <a:fillRect/>
           </a:stretch>
@@ -4706,7 +4639,7 @@
           </a:prstGeom>
           <a:extLst>
             <a:ext uri="{C572A759-6A51-4108-AA02-DFA0A04FC94B}">
-              <ma14:wrappingTextBoxFlag xmlns:ma14="http://schemas.microsoft.com/office/mac/drawingml/2011/main" val="0"/>
+              <ma14:wrappingTextBoxFlag xmlns:ma14="http://schemas.microsoft.com/office/mac/drawingml/2011/main" xmlns="" val="0"/>
             </a:ext>
           </a:extLst>
         </p:spPr>
@@ -4727,7 +4660,7 @@
           <a:p>
             <a:pPr algn="r"/>
             <a:fld id="{F7021451-1387-4CA6-816F-3879F97B5CBC}" type="slidenum">
-              <a:rPr b="0" lang="en-US"/>
+              <a:rPr lang="en-US" b="0"/>
               <a:t>13</a:t>
             </a:fld>
             <a:endParaRPr lang="en-US"/>
@@ -4780,7 +4713,7 @@
           <a:bodyPr wrap="square" lIns="0" tIns="0" rIns="0" bIns="0" rtlCol="0" anchor="ctr"/>
           <a:lstStyle/>
           <a:p>
-            <a:pPr indent="0" marL="0">
+            <a:pPr marL="0" indent="0">
               <a:buNone/>
             </a:pPr>
             <a:r>
@@ -4819,7 +4752,7 @@
           <a:bodyPr wrap="square" lIns="0" tIns="0" rIns="0" bIns="0" rtlCol="0" anchor="ctr"/>
           <a:lstStyle/>
           <a:p>
-            <a:pPr indent="0" marL="0">
+            <a:pPr marL="0" indent="0">
               <a:buNone/>
             </a:pPr>
             <a:r>
@@ -4861,6 +4794,13 @@
             <a:prstDash val="solid"/>
           </a:ln>
         </p:spPr>
+        <p:txBody>
+          <a:bodyPr/>
+          <a:lstStyle/>
+          <a:p>
+            <a:endParaRPr lang="en-US"/>
+          </a:p>
+        </p:txBody>
       </p:sp>
       <p:sp>
         <p:nvSpPr>
@@ -4885,7 +4825,7 @@
           </a:bodyPr>
           <a:lstStyle/>
           <a:p>
-            <a:pPr algn="ctr" indent="0" marL="0">
+            <a:pPr marL="0" indent="0" algn="ctr">
               <a:buNone/>
             </a:pPr>
             <a:r>
@@ -4905,14 +4845,14 @@
       </p:sp>
       <p:pic>
         <p:nvPicPr>
-          <p:cNvPr id="6" name="Image 0" descr="/mnt/data/week8_random_signals/assets/autocorr_matrix.png">    </p:cNvPr>
+          <p:cNvPr id="6" name="Image 0" descr="/mnt/data/week8_random_signals/assets/autocorr_matrix.png"/>
           <p:cNvPicPr>
             <a:picLocks noChangeAspect="1"/>
           </p:cNvPicPr>
           <p:nvPr/>
         </p:nvPicPr>
         <p:blipFill>
-          <a:blip r:embed="rId1"/>
+          <a:blip r:embed="rId3"/>
           <a:stretch>
             <a:fillRect/>
           </a:stretch>
@@ -5043,7 +4983,7 @@
           </a:prstGeom>
           <a:extLst>
             <a:ext uri="{C572A759-6A51-4108-AA02-DFA0A04FC94B}">
-              <ma14:wrappingTextBoxFlag xmlns:ma14="http://schemas.microsoft.com/office/mac/drawingml/2011/main" val="0"/>
+              <ma14:wrappingTextBoxFlag xmlns:ma14="http://schemas.microsoft.com/office/mac/drawingml/2011/main" xmlns="" val="0"/>
             </a:ext>
           </a:extLst>
         </p:spPr>
@@ -5064,7 +5004,7 @@
           <a:p>
             <a:pPr algn="r"/>
             <a:fld id="{F7021451-1387-4CA6-816F-3879F97B5CBC}" type="slidenum">
-              <a:rPr b="0" lang="en-US"/>
+              <a:rPr lang="en-US" b="0"/>
               <a:t>14</a:t>
             </a:fld>
             <a:endParaRPr lang="en-US"/>
@@ -5120,6 +5060,13 @@
             <a:prstDash val="solid"/>
           </a:ln>
         </p:spPr>
+        <p:txBody>
+          <a:bodyPr/>
+          <a:lstStyle/>
+          <a:p>
+            <a:endParaRPr lang="en-US"/>
+          </a:p>
+        </p:txBody>
       </p:sp>
       <p:sp>
         <p:nvSpPr>
@@ -5142,7 +5089,7 @@
           <a:bodyPr wrap="square" lIns="0" tIns="0" rIns="0" bIns="0" rtlCol="0" anchor="ctr"/>
           <a:lstStyle/>
           <a:p>
-            <a:pPr indent="0" marL="0">
+            <a:pPr marL="0" indent="0">
               <a:buNone/>
             </a:pPr>
             <a:r>
@@ -5183,7 +5130,7 @@
           </a:bodyPr>
           <a:lstStyle/>
           <a:p>
-            <a:pPr indent="0" marL="0">
+            <a:pPr marL="0" indent="0">
               <a:buNone/>
             </a:pPr>
             <a:r>
@@ -5222,7 +5169,7 @@
           <a:bodyPr wrap="square" lIns="0" tIns="0" rIns="0" bIns="0" rtlCol="0" anchor="ctr"/>
           <a:lstStyle/>
           <a:p>
-            <a:pPr indent="0" marL="0">
+            <a:pPr marL="0" indent="0">
               <a:buNone/>
             </a:pPr>
             <a:r>
@@ -5263,7 +5210,7 @@
           </a:bodyPr>
           <a:lstStyle/>
           <a:p>
-            <a:pPr indent="0" marL="0">
+            <a:pPr marL="0" indent="0">
               <a:buNone/>
             </a:pPr>
             <a:r>
@@ -5301,7 +5248,7 @@
           </a:prstGeom>
           <a:extLst>
             <a:ext uri="{C572A759-6A51-4108-AA02-DFA0A04FC94B}">
-              <ma14:wrappingTextBoxFlag xmlns:ma14="http://schemas.microsoft.com/office/mac/drawingml/2011/main" val="0"/>
+              <ma14:wrappingTextBoxFlag xmlns:ma14="http://schemas.microsoft.com/office/mac/drawingml/2011/main" xmlns="" val="0"/>
             </a:ext>
           </a:extLst>
         </p:spPr>
@@ -5322,7 +5269,7 @@
           <a:p>
             <a:pPr algn="r"/>
             <a:fld id="{F7021451-1387-4CA6-816F-3879F97B5CBC}" type="slidenum">
-              <a:rPr b="0" lang="en-US"/>
+              <a:rPr lang="en-US" b="0"/>
               <a:t>15</a:t>
             </a:fld>
             <a:endParaRPr lang="en-US"/>
@@ -5345,6 +5292,7 @@
         <a:solidFill>
           <a:srgbClr val="17324D"/>
         </a:solidFill>
+        <a:effectLst/>
       </p:bgPr>
     </p:bg>
     <p:spTree>
@@ -5382,7 +5330,7 @@
           <a:bodyPr wrap="square" lIns="0" tIns="0" rIns="0" bIns="0" rtlCol="0" anchor="ctr"/>
           <a:lstStyle/>
           <a:p>
-            <a:pPr indent="0" marL="0">
+            <a:pPr marL="0" indent="0">
               <a:buNone/>
             </a:pPr>
             <a:r>
@@ -5421,7 +5369,7 @@
           <a:bodyPr wrap="square" lIns="0" tIns="0" rIns="0" bIns="0" rtlCol="0" anchor="ctr"/>
           <a:lstStyle/>
           <a:p>
-            <a:pPr indent="0" marL="0">
+            <a:pPr marL="0" indent="0">
               <a:buNone/>
             </a:pPr>
             <a:r>
@@ -5460,7 +5408,7 @@
           <a:bodyPr wrap="square" lIns="0" tIns="0" rIns="0" bIns="0" rtlCol="0" anchor="ctr"/>
           <a:lstStyle/>
           <a:p>
-            <a:pPr indent="0" marL="0">
+            <a:pPr marL="0" indent="0">
               <a:buNone/>
             </a:pPr>
             <a:r>
@@ -5498,7 +5446,7 @@
           </a:prstGeom>
           <a:extLst>
             <a:ext uri="{C572A759-6A51-4108-AA02-DFA0A04FC94B}">
-              <ma14:wrappingTextBoxFlag xmlns:ma14="http://schemas.microsoft.com/office/mac/drawingml/2011/main" val="0"/>
+              <ma14:wrappingTextBoxFlag xmlns:ma14="http://schemas.microsoft.com/office/mac/drawingml/2011/main" xmlns="" val="0"/>
             </a:ext>
           </a:extLst>
         </p:spPr>
@@ -5519,7 +5467,7 @@
           <a:p>
             <a:pPr algn="r"/>
             <a:fld id="{F7021451-1387-4CA6-816F-3879F97B5CBC}" type="slidenum">
-              <a:rPr b="0" lang="en-US"/>
+              <a:rPr lang="en-US" b="0"/>
               <a:t>16</a:t>
             </a:fld>
             <a:endParaRPr lang="en-US"/>
@@ -5572,7 +5520,7 @@
           <a:bodyPr wrap="square" lIns="0" tIns="0" rIns="0" bIns="0" rtlCol="0" anchor="ctr"/>
           <a:lstStyle/>
           <a:p>
-            <a:pPr indent="0" marL="0">
+            <a:pPr marL="0" indent="0">
               <a:buNone/>
             </a:pPr>
             <a:r>
@@ -5611,7 +5559,7 @@
           <a:bodyPr wrap="square" lIns="0" tIns="0" rIns="0" bIns="0" rtlCol="0" anchor="ctr"/>
           <a:lstStyle/>
           <a:p>
-            <a:pPr indent="0" marL="0">
+            <a:pPr marL="0" indent="0">
               <a:buNone/>
             </a:pPr>
             <a:r>
@@ -5631,14 +5579,14 @@
       </p:sp>
       <p:pic>
         <p:nvPicPr>
-          <p:cNvPr id="4" name="Image 0" descr="/mnt/data/week8_random_signals/assets/template_matching.png">    </p:cNvPr>
+          <p:cNvPr id="4" name="Image 0" descr="/mnt/data/week8_random_signals/assets/template_matching.png"/>
           <p:cNvPicPr>
             <a:picLocks noChangeAspect="1"/>
           </p:cNvPicPr>
           <p:nvPr/>
         </p:nvPicPr>
         <p:blipFill>
-          <a:blip r:embed="rId1"/>
+          <a:blip r:embed="rId3"/>
           <a:stretch>
             <a:fillRect/>
           </a:stretch>
@@ -5775,6 +5723,13 @@
             <a:prstDash val="solid"/>
           </a:ln>
         </p:spPr>
+        <p:txBody>
+          <a:bodyPr/>
+          <a:lstStyle/>
+          <a:p>
+            <a:endParaRPr lang="en-US"/>
+          </a:p>
+        </p:txBody>
       </p:sp>
       <p:sp>
         <p:nvSpPr>
@@ -5800,6 +5755,13 @@
             <a:prstDash val="solid"/>
           </a:ln>
         </p:spPr>
+        <p:txBody>
+          <a:bodyPr/>
+          <a:lstStyle/>
+          <a:p>
+            <a:endParaRPr lang="en-US"/>
+          </a:p>
+        </p:txBody>
       </p:sp>
       <p:sp>
         <p:nvSpPr>
@@ -5822,7 +5784,7 @@
           <a:bodyPr wrap="square" lIns="0" tIns="0" rIns="0" bIns="0" rtlCol="0" anchor="ctr"/>
           <a:lstStyle/>
           <a:p>
-            <a:pPr indent="0" marL="0">
+            <a:pPr marL="0" indent="0">
               <a:buNone/>
             </a:pPr>
             <a:r>
@@ -5859,11 +5821,11 @@
         </p:spPr>
         <p:txBody>
           <a:bodyPr wrap="square" lIns="0" tIns="0" rIns="0" bIns="0" rtlCol="0" anchor="t">
-            <a:normAutofit/>
+            <a:normAutofit fontScale="62500" lnSpcReduction="20000"/>
           </a:bodyPr>
           <a:lstStyle/>
           <a:p>
-            <a:pPr indent="0" marL="0">
+            <a:pPr marL="0" indent="0">
               <a:buNone/>
             </a:pPr>
             <a:r>
@@ -5901,7 +5863,7 @@
           </a:prstGeom>
           <a:extLst>
             <a:ext uri="{C572A759-6A51-4108-AA02-DFA0A04FC94B}">
-              <ma14:wrappingTextBoxFlag xmlns:ma14="http://schemas.microsoft.com/office/mac/drawingml/2011/main" val="0"/>
+              <ma14:wrappingTextBoxFlag xmlns:ma14="http://schemas.microsoft.com/office/mac/drawingml/2011/main" xmlns="" val="0"/>
             </a:ext>
           </a:extLst>
         </p:spPr>
@@ -5922,7 +5884,7 @@
           <a:p>
             <a:pPr algn="r"/>
             <a:fld id="{F7021451-1387-4CA6-816F-3879F97B5CBC}" type="slidenum">
-              <a:rPr b="0" lang="en-US"/>
+              <a:rPr lang="en-US" b="0"/>
               <a:t>17</a:t>
             </a:fld>
             <a:endParaRPr lang="en-US"/>
@@ -5975,7 +5937,7 @@
           <a:bodyPr wrap="square" lIns="0" tIns="0" rIns="0" bIns="0" rtlCol="0" anchor="ctr"/>
           <a:lstStyle/>
           <a:p>
-            <a:pPr indent="0" marL="0">
+            <a:pPr marL="0" indent="0">
               <a:buNone/>
             </a:pPr>
             <a:r>
@@ -6014,7 +5976,7 @@
           <a:bodyPr wrap="square" lIns="0" tIns="0" rIns="0" bIns="0" rtlCol="0" anchor="ctr"/>
           <a:lstStyle/>
           <a:p>
-            <a:pPr indent="0" marL="0">
+            <a:pPr marL="0" indent="0">
               <a:buNone/>
             </a:pPr>
             <a:r>
@@ -6053,7 +6015,7 @@
           <a:bodyPr wrap="square" lIns="0" tIns="0" rIns="0" bIns="0" rtlCol="0" anchor="ctr"/>
           <a:lstStyle/>
           <a:p>
-            <a:pPr indent="0" marL="0">
+            <a:pPr marL="0" indent="0">
               <a:buNone/>
             </a:pPr>
             <a:r>
@@ -6094,6 +6056,13 @@
             <a:prstDash val="solid"/>
           </a:ln>
         </p:spPr>
+        <p:txBody>
+          <a:bodyPr/>
+          <a:lstStyle/>
+          <a:p>
+            <a:endParaRPr lang="en-US"/>
+          </a:p>
+        </p:txBody>
       </p:sp>
       <p:sp>
         <p:nvSpPr>
@@ -6119,6 +6088,13 @@
             <a:prstDash val="solid"/>
           </a:ln>
         </p:spPr>
+        <p:txBody>
+          <a:bodyPr/>
+          <a:lstStyle/>
+          <a:p>
+            <a:endParaRPr lang="en-US"/>
+          </a:p>
+        </p:txBody>
       </p:sp>
       <p:sp>
         <p:nvSpPr>
@@ -6141,7 +6117,7 @@
           <a:bodyPr wrap="square" lIns="0" tIns="0" rIns="0" bIns="0" rtlCol="0" anchor="ctr"/>
           <a:lstStyle/>
           <a:p>
-            <a:pPr indent="0" marL="0">
+            <a:pPr marL="0" indent="0">
               <a:buNone/>
             </a:pPr>
             <a:r>
@@ -6182,7 +6158,7 @@
           </a:bodyPr>
           <a:lstStyle/>
           <a:p>
-            <a:pPr indent="0" marL="0">
+            <a:pPr marL="0" indent="0">
               <a:buNone/>
             </a:pPr>
             <a:r>
@@ -6221,7 +6197,7 @@
           <a:bodyPr wrap="square" lIns="0" tIns="0" rIns="0" bIns="0" rtlCol="0" anchor="ctr"/>
           <a:lstStyle/>
           <a:p>
-            <a:pPr indent="0" marL="0">
+            <a:pPr marL="0" indent="0">
               <a:buNone/>
             </a:pPr>
             <a:r>
@@ -6262,6 +6238,13 @@
             <a:prstDash val="solid"/>
           </a:ln>
         </p:spPr>
+        <p:txBody>
+          <a:bodyPr/>
+          <a:lstStyle/>
+          <a:p>
+            <a:endParaRPr lang="en-US"/>
+          </a:p>
+        </p:txBody>
       </p:sp>
       <p:sp>
         <p:nvSpPr>
@@ -6287,6 +6270,13 @@
             <a:prstDash val="solid"/>
           </a:ln>
         </p:spPr>
+        <p:txBody>
+          <a:bodyPr/>
+          <a:lstStyle/>
+          <a:p>
+            <a:endParaRPr lang="en-US"/>
+          </a:p>
+        </p:txBody>
       </p:sp>
       <p:sp>
         <p:nvSpPr>
@@ -6309,7 +6299,7 @@
           <a:bodyPr wrap="square" lIns="0" tIns="0" rIns="0" bIns="0" rtlCol="0" anchor="ctr"/>
           <a:lstStyle/>
           <a:p>
-            <a:pPr indent="0" marL="0">
+            <a:pPr marL="0" indent="0">
               <a:buNone/>
             </a:pPr>
             <a:r>
@@ -6350,7 +6340,7 @@
           </a:bodyPr>
           <a:lstStyle/>
           <a:p>
-            <a:pPr indent="0" marL="0">
+            <a:pPr marL="0" indent="0">
               <a:buNone/>
             </a:pPr>
             <a:r>
@@ -6389,7 +6379,7 @@
           <a:bodyPr wrap="square" lIns="0" tIns="0" rIns="0" bIns="0" rtlCol="0" anchor="ctr"/>
           <a:lstStyle/>
           <a:p>
-            <a:pPr indent="0" marL="0">
+            <a:pPr marL="0" indent="0">
               <a:buNone/>
             </a:pPr>
             <a:r>
@@ -6430,6 +6420,13 @@
             <a:prstDash val="solid"/>
           </a:ln>
         </p:spPr>
+        <p:txBody>
+          <a:bodyPr/>
+          <a:lstStyle/>
+          <a:p>
+            <a:endParaRPr lang="en-US"/>
+          </a:p>
+        </p:txBody>
       </p:sp>
       <p:sp>
         <p:nvSpPr>
@@ -6455,6 +6452,13 @@
             <a:prstDash val="solid"/>
           </a:ln>
         </p:spPr>
+        <p:txBody>
+          <a:bodyPr/>
+          <a:lstStyle/>
+          <a:p>
+            <a:endParaRPr lang="en-US"/>
+          </a:p>
+        </p:txBody>
       </p:sp>
       <p:sp>
         <p:nvSpPr>
@@ -6477,7 +6481,7 @@
           <a:bodyPr wrap="square" lIns="0" tIns="0" rIns="0" bIns="0" rtlCol="0" anchor="ctr"/>
           <a:lstStyle/>
           <a:p>
-            <a:pPr indent="0" marL="0">
+            <a:pPr marL="0" indent="0">
               <a:buNone/>
             </a:pPr>
             <a:r>
@@ -6518,7 +6522,7 @@
           </a:bodyPr>
           <a:lstStyle/>
           <a:p>
-            <a:pPr indent="0" marL="0">
+            <a:pPr marL="0" indent="0">
               <a:buNone/>
             </a:pPr>
             <a:r>
@@ -6562,6 +6566,13 @@
             <a:prstDash val="solid"/>
           </a:ln>
         </p:spPr>
+        <p:txBody>
+          <a:bodyPr/>
+          <a:lstStyle/>
+          <a:p>
+            <a:endParaRPr lang="en-US"/>
+          </a:p>
+        </p:txBody>
       </p:sp>
       <p:sp>
         <p:nvSpPr>
@@ -6587,6 +6598,13 @@
             <a:prstDash val="solid"/>
           </a:ln>
         </p:spPr>
+        <p:txBody>
+          <a:bodyPr/>
+          <a:lstStyle/>
+          <a:p>
+            <a:endParaRPr lang="en-US"/>
+          </a:p>
+        </p:txBody>
       </p:sp>
       <p:sp>
         <p:nvSpPr>
@@ -6609,7 +6627,7 @@
           <a:bodyPr wrap="square" lIns="0" tIns="0" rIns="0" bIns="0" rtlCol="0" anchor="ctr"/>
           <a:lstStyle/>
           <a:p>
-            <a:pPr indent="0" marL="0">
+            <a:pPr marL="0" indent="0">
               <a:buNone/>
             </a:pPr>
             <a:r>
@@ -6650,7 +6668,7 @@
           </a:bodyPr>
           <a:lstStyle/>
           <a:p>
-            <a:pPr indent="0" marL="0">
+            <a:pPr marL="0" indent="0">
               <a:buNone/>
             </a:pPr>
             <a:r>
@@ -6688,7 +6706,7 @@
           </a:prstGeom>
           <a:extLst>
             <a:ext uri="{C572A759-6A51-4108-AA02-DFA0A04FC94B}">
-              <ma14:wrappingTextBoxFlag xmlns:ma14="http://schemas.microsoft.com/office/mac/drawingml/2011/main" val="0"/>
+              <ma14:wrappingTextBoxFlag xmlns:ma14="http://schemas.microsoft.com/office/mac/drawingml/2011/main" xmlns="" val="0"/>
             </a:ext>
           </a:extLst>
         </p:spPr>
@@ -6709,7 +6727,7 @@
           <a:p>
             <a:pPr algn="r"/>
             <a:fld id="{F7021451-1387-4CA6-816F-3879F97B5CBC}" type="slidenum">
-              <a:rPr b="0" lang="en-US"/>
+              <a:rPr lang="en-US" b="0"/>
               <a:t>18</a:t>
             </a:fld>
             <a:endParaRPr lang="en-US"/>
@@ -6762,7 +6780,7 @@
           <a:bodyPr wrap="square" lIns="0" tIns="0" rIns="0" bIns="0" rtlCol="0" anchor="ctr"/>
           <a:lstStyle/>
           <a:p>
-            <a:pPr indent="0" marL="0">
+            <a:pPr marL="0" indent="0">
               <a:buNone/>
             </a:pPr>
             <a:r>
@@ -6801,7 +6819,7 @@
           <a:bodyPr wrap="square" lIns="0" tIns="0" rIns="0" bIns="0" rtlCol="0" anchor="ctr"/>
           <a:lstStyle/>
           <a:p>
-            <a:pPr indent="0" marL="0">
+            <a:pPr marL="0" indent="0">
               <a:buNone/>
             </a:pPr>
             <a:r>
@@ -6959,6 +6977,13 @@
             <a:prstDash val="solid"/>
           </a:ln>
         </p:spPr>
+        <p:txBody>
+          <a:bodyPr/>
+          <a:lstStyle/>
+          <a:p>
+            <a:endParaRPr lang="en-US"/>
+          </a:p>
+        </p:txBody>
       </p:sp>
       <p:sp>
         <p:nvSpPr>
@@ -6984,6 +7009,13 @@
             <a:prstDash val="solid"/>
           </a:ln>
         </p:spPr>
+        <p:txBody>
+          <a:bodyPr/>
+          <a:lstStyle/>
+          <a:p>
+            <a:endParaRPr lang="en-US"/>
+          </a:p>
+        </p:txBody>
       </p:sp>
       <p:sp>
         <p:nvSpPr>
@@ -7006,7 +7038,7 @@
           <a:bodyPr wrap="square" lIns="0" tIns="0" rIns="0" bIns="0" rtlCol="0" anchor="ctr"/>
           <a:lstStyle/>
           <a:p>
-            <a:pPr indent="0" marL="0">
+            <a:pPr marL="0" indent="0">
               <a:buNone/>
             </a:pPr>
             <a:r>
@@ -7047,7 +7079,7 @@
           </a:bodyPr>
           <a:lstStyle/>
           <a:p>
-            <a:pPr indent="0" marL="0">
+            <a:pPr marL="0" indent="0">
               <a:buNone/>
             </a:pPr>
             <a:r>
@@ -7091,6 +7123,13 @@
             <a:prstDash val="solid"/>
           </a:ln>
         </p:spPr>
+        <p:txBody>
+          <a:bodyPr/>
+          <a:lstStyle/>
+          <a:p>
+            <a:endParaRPr lang="en-US"/>
+          </a:p>
+        </p:txBody>
       </p:sp>
       <p:sp>
         <p:nvSpPr>
@@ -7116,6 +7155,13 @@
             <a:prstDash val="solid"/>
           </a:ln>
         </p:spPr>
+        <p:txBody>
+          <a:bodyPr/>
+          <a:lstStyle/>
+          <a:p>
+            <a:endParaRPr lang="en-US"/>
+          </a:p>
+        </p:txBody>
       </p:sp>
       <p:sp>
         <p:nvSpPr>
@@ -7138,7 +7184,7 @@
           <a:bodyPr wrap="square" lIns="0" tIns="0" rIns="0" bIns="0" rtlCol="0" anchor="ctr"/>
           <a:lstStyle/>
           <a:p>
-            <a:pPr indent="0" marL="0">
+            <a:pPr marL="0" indent="0">
               <a:buNone/>
             </a:pPr>
             <a:r>
@@ -7179,7 +7225,7 @@
           </a:bodyPr>
           <a:lstStyle/>
           <a:p>
-            <a:pPr indent="0" marL="0">
+            <a:pPr marL="0" indent="0">
               <a:buNone/>
             </a:pPr>
             <a:r>
@@ -7217,7 +7263,7 @@
           </a:prstGeom>
           <a:extLst>
             <a:ext uri="{C572A759-6A51-4108-AA02-DFA0A04FC94B}">
-              <ma14:wrappingTextBoxFlag xmlns:ma14="http://schemas.microsoft.com/office/mac/drawingml/2011/main" val="0"/>
+              <ma14:wrappingTextBoxFlag xmlns:ma14="http://schemas.microsoft.com/office/mac/drawingml/2011/main" xmlns="" val="0"/>
             </a:ext>
           </a:extLst>
         </p:spPr>
@@ -7238,7 +7284,7 @@
           <a:p>
             <a:pPr algn="r"/>
             <a:fld id="{F7021451-1387-4CA6-816F-3879F97B5CBC}" type="slidenum">
-              <a:rPr b="0" lang="en-US"/>
+              <a:rPr lang="en-US" b="0"/>
               <a:t>19</a:t>
             </a:fld>
             <a:endParaRPr lang="en-US"/>
@@ -7291,7 +7337,7 @@
           <a:bodyPr wrap="square" lIns="0" tIns="0" rIns="0" bIns="0" rtlCol="0" anchor="ctr"/>
           <a:lstStyle/>
           <a:p>
-            <a:pPr indent="0" marL="0">
+            <a:pPr marL="0" indent="0">
               <a:buNone/>
             </a:pPr>
             <a:r>
@@ -7330,7 +7376,7 @@
           <a:bodyPr wrap="square" lIns="0" tIns="0" rIns="0" bIns="0" rtlCol="0" anchor="ctr"/>
           <a:lstStyle/>
           <a:p>
-            <a:pPr indent="0" marL="0">
+            <a:pPr marL="0" indent="0">
               <a:buNone/>
             </a:pPr>
             <a:r>
@@ -7470,6 +7516,13 @@
             <a:prstDash val="solid"/>
           </a:ln>
         </p:spPr>
+        <p:txBody>
+          <a:bodyPr/>
+          <a:lstStyle/>
+          <a:p>
+            <a:endParaRPr lang="en-US"/>
+          </a:p>
+        </p:txBody>
       </p:sp>
       <p:sp>
         <p:nvSpPr>
@@ -7495,6 +7548,13 @@
             <a:prstDash val="solid"/>
           </a:ln>
         </p:spPr>
+        <p:txBody>
+          <a:bodyPr/>
+          <a:lstStyle/>
+          <a:p>
+            <a:endParaRPr lang="en-US"/>
+          </a:p>
+        </p:txBody>
       </p:sp>
       <p:sp>
         <p:nvSpPr>
@@ -7517,7 +7577,7 @@
           <a:bodyPr wrap="square" lIns="0" tIns="0" rIns="0" bIns="0" rtlCol="0" anchor="ctr"/>
           <a:lstStyle/>
           <a:p>
-            <a:pPr indent="0" marL="0">
+            <a:pPr marL="0" indent="0">
               <a:buNone/>
             </a:pPr>
             <a:r>
@@ -7558,7 +7618,7 @@
           </a:bodyPr>
           <a:lstStyle/>
           <a:p>
-            <a:pPr indent="0" marL="0">
+            <a:pPr marL="0" indent="0">
               <a:buNone/>
             </a:pPr>
             <a:r>
@@ -7602,6 +7662,13 @@
             <a:prstDash val="solid"/>
           </a:ln>
         </p:spPr>
+        <p:txBody>
+          <a:bodyPr/>
+          <a:lstStyle/>
+          <a:p>
+            <a:endParaRPr lang="en-US"/>
+          </a:p>
+        </p:txBody>
       </p:sp>
       <p:sp>
         <p:nvSpPr>
@@ -7627,6 +7694,13 @@
             <a:prstDash val="solid"/>
           </a:ln>
         </p:spPr>
+        <p:txBody>
+          <a:bodyPr/>
+          <a:lstStyle/>
+          <a:p>
+            <a:endParaRPr lang="en-US"/>
+          </a:p>
+        </p:txBody>
       </p:sp>
       <p:sp>
         <p:nvSpPr>
@@ -7649,7 +7723,7 @@
           <a:bodyPr wrap="square" lIns="0" tIns="0" rIns="0" bIns="0" rtlCol="0" anchor="ctr"/>
           <a:lstStyle/>
           <a:p>
-            <a:pPr indent="0" marL="0">
+            <a:pPr marL="0" indent="0">
               <a:buNone/>
             </a:pPr>
             <a:r>
@@ -7690,7 +7764,7 @@
           </a:bodyPr>
           <a:lstStyle/>
           <a:p>
-            <a:pPr indent="0" marL="0">
+            <a:pPr marL="0" indent="0">
               <a:buNone/>
             </a:pPr>
             <a:r>
@@ -7734,6 +7808,13 @@
             <a:prstDash val="solid"/>
           </a:ln>
         </p:spPr>
+        <p:txBody>
+          <a:bodyPr/>
+          <a:lstStyle/>
+          <a:p>
+            <a:endParaRPr lang="en-US"/>
+          </a:p>
+        </p:txBody>
       </p:sp>
       <p:sp>
         <p:nvSpPr>
@@ -7759,6 +7840,13 @@
             <a:prstDash val="solid"/>
           </a:ln>
         </p:spPr>
+        <p:txBody>
+          <a:bodyPr/>
+          <a:lstStyle/>
+          <a:p>
+            <a:endParaRPr lang="en-US"/>
+          </a:p>
+        </p:txBody>
       </p:sp>
       <p:sp>
         <p:nvSpPr>
@@ -7781,7 +7869,7 @@
           <a:bodyPr wrap="square" lIns="0" tIns="0" rIns="0" bIns="0" rtlCol="0" anchor="ctr"/>
           <a:lstStyle/>
           <a:p>
-            <a:pPr indent="0" marL="0">
+            <a:pPr marL="0" indent="0">
               <a:buNone/>
             </a:pPr>
             <a:r>
@@ -7822,7 +7910,7 @@
           </a:bodyPr>
           <a:lstStyle/>
           <a:p>
-            <a:pPr indent="0" marL="0">
+            <a:pPr marL="0" indent="0">
               <a:buNone/>
             </a:pPr>
             <a:r>
@@ -7866,6 +7954,13 @@
             <a:prstDash val="solid"/>
           </a:ln>
         </p:spPr>
+        <p:txBody>
+          <a:bodyPr/>
+          <a:lstStyle/>
+          <a:p>
+            <a:endParaRPr lang="en-US"/>
+          </a:p>
+        </p:txBody>
       </p:sp>
       <p:sp>
         <p:nvSpPr>
@@ -7891,6 +7986,13 @@
             <a:prstDash val="solid"/>
           </a:ln>
         </p:spPr>
+        <p:txBody>
+          <a:bodyPr/>
+          <a:lstStyle/>
+          <a:p>
+            <a:endParaRPr lang="en-US"/>
+          </a:p>
+        </p:txBody>
       </p:sp>
       <p:sp>
         <p:nvSpPr>
@@ -7913,7 +8015,7 @@
           <a:bodyPr wrap="square" lIns="0" tIns="0" rIns="0" bIns="0" rtlCol="0" anchor="ctr"/>
           <a:lstStyle/>
           <a:p>
-            <a:pPr indent="0" marL="0">
+            <a:pPr marL="0" indent="0">
               <a:buNone/>
             </a:pPr>
             <a:r>
@@ -7950,11 +8052,11 @@
         </p:spPr>
         <p:txBody>
           <a:bodyPr wrap="square" lIns="0" tIns="0" rIns="0" bIns="0" rtlCol="0" anchor="t">
-            <a:normAutofit/>
+            <a:normAutofit fontScale="32500" lnSpcReduction="20000"/>
           </a:bodyPr>
           <a:lstStyle/>
           <a:p>
-            <a:pPr indent="0" marL="0">
+            <a:pPr marL="0" indent="0">
               <a:buNone/>
             </a:pPr>
             <a:r>
@@ -7992,7 +8094,7 @@
           </a:prstGeom>
           <a:extLst>
             <a:ext uri="{C572A759-6A51-4108-AA02-DFA0A04FC94B}">
-              <ma14:wrappingTextBoxFlag xmlns:ma14="http://schemas.microsoft.com/office/mac/drawingml/2011/main" val="0"/>
+              <ma14:wrappingTextBoxFlag xmlns:ma14="http://schemas.microsoft.com/office/mac/drawingml/2011/main" xmlns="" val="0"/>
             </a:ext>
           </a:extLst>
         </p:spPr>
@@ -8013,7 +8115,7 @@
           <a:p>
             <a:pPr algn="r"/>
             <a:fld id="{F7021451-1387-4CA6-816F-3879F97B5CBC}" type="slidenum">
-              <a:rPr b="0" lang="en-US"/>
+              <a:rPr lang="en-US" b="0"/>
               <a:t>2</a:t>
             </a:fld>
             <a:endParaRPr lang="en-US"/>
@@ -8066,7 +8168,7 @@
           <a:bodyPr wrap="square" lIns="0" tIns="0" rIns="0" bIns="0" rtlCol="0" anchor="ctr"/>
           <a:lstStyle/>
           <a:p>
-            <a:pPr indent="0" marL="0">
+            <a:pPr marL="0" indent="0">
               <a:buNone/>
             </a:pPr>
             <a:r>
@@ -8200,7 +8302,7 @@
           </a:prstGeom>
           <a:extLst>
             <a:ext uri="{C572A759-6A51-4108-AA02-DFA0A04FC94B}">
-              <ma14:wrappingTextBoxFlag xmlns:ma14="http://schemas.microsoft.com/office/mac/drawingml/2011/main" val="0"/>
+              <ma14:wrappingTextBoxFlag xmlns:ma14="http://schemas.microsoft.com/office/mac/drawingml/2011/main" xmlns="" val="0"/>
             </a:ext>
           </a:extLst>
         </p:spPr>
@@ -8221,7 +8323,7 @@
           <a:p>
             <a:pPr algn="r"/>
             <a:fld id="{F7021451-1387-4CA6-816F-3879F97B5CBC}" type="slidenum">
-              <a:rPr b="0" lang="en-US"/>
+              <a:rPr lang="en-US" b="0"/>
               <a:t>20</a:t>
             </a:fld>
             <a:endParaRPr lang="en-US"/>
@@ -8244,6 +8346,7 @@
         <a:solidFill>
           <a:srgbClr val="17324D"/>
         </a:solidFill>
+        <a:effectLst/>
       </p:bgPr>
     </p:bg>
     <p:spTree>
@@ -8281,7 +8384,7 @@
           <a:bodyPr wrap="square" lIns="0" tIns="0" rIns="0" bIns="0" rtlCol="0" anchor="ctr"/>
           <a:lstStyle/>
           <a:p>
-            <a:pPr indent="0" marL="0">
+            <a:pPr marL="0" indent="0">
               <a:buNone/>
             </a:pPr>
             <a:r>
@@ -8320,7 +8423,7 @@
           <a:bodyPr wrap="square" lIns="0" tIns="0" rIns="0" bIns="0" rtlCol="0" anchor="ctr"/>
           <a:lstStyle/>
           <a:p>
-            <a:pPr indent="0" marL="0">
+            <a:pPr marL="0" indent="0">
               <a:buNone/>
             </a:pPr>
             <a:r>
@@ -8359,7 +8462,7 @@
           <a:bodyPr wrap="square" lIns="0" tIns="0" rIns="0" bIns="0" rtlCol="0" anchor="ctr"/>
           <a:lstStyle/>
           <a:p>
-            <a:pPr indent="0" marL="0">
+            <a:pPr marL="0" indent="0">
               <a:buNone/>
             </a:pPr>
             <a:r>
@@ -8397,7 +8500,7 @@
           </a:prstGeom>
           <a:extLst>
             <a:ext uri="{C572A759-6A51-4108-AA02-DFA0A04FC94B}">
-              <ma14:wrappingTextBoxFlag xmlns:ma14="http://schemas.microsoft.com/office/mac/drawingml/2011/main" val="0"/>
+              <ma14:wrappingTextBoxFlag xmlns:ma14="http://schemas.microsoft.com/office/mac/drawingml/2011/main" xmlns="" val="0"/>
             </a:ext>
           </a:extLst>
         </p:spPr>
@@ -8418,7 +8521,7 @@
           <a:p>
             <a:pPr algn="r"/>
             <a:fld id="{F7021451-1387-4CA6-816F-3879F97B5CBC}" type="slidenum">
-              <a:rPr b="0" lang="en-US"/>
+              <a:rPr lang="en-US" b="0"/>
               <a:t>3</a:t>
             </a:fld>
             <a:endParaRPr lang="en-US"/>
@@ -8471,7 +8574,7 @@
           <a:bodyPr wrap="square" lIns="0" tIns="0" rIns="0" bIns="0" rtlCol="0" anchor="ctr"/>
           <a:lstStyle/>
           <a:p>
-            <a:pPr indent="0" marL="0">
+            <a:pPr marL="0" indent="0">
               <a:buNone/>
             </a:pPr>
             <a:r>
@@ -8510,7 +8613,7 @@
           <a:bodyPr wrap="square" lIns="0" tIns="0" rIns="0" bIns="0" rtlCol="0" anchor="ctr"/>
           <a:lstStyle/>
           <a:p>
-            <a:pPr indent="0" marL="0">
+            <a:pPr marL="0" indent="0">
               <a:buNone/>
             </a:pPr>
             <a:r>
@@ -8552,6 +8655,13 @@
             <a:prstDash val="solid"/>
           </a:ln>
         </p:spPr>
+        <p:txBody>
+          <a:bodyPr/>
+          <a:lstStyle/>
+          <a:p>
+            <a:endParaRPr lang="en-US"/>
+          </a:p>
+        </p:txBody>
       </p:sp>
       <p:sp>
         <p:nvSpPr>
@@ -8576,7 +8686,7 @@
           </a:bodyPr>
           <a:lstStyle/>
           <a:p>
-            <a:pPr algn="ctr" indent="0" marL="0">
+            <a:pPr marL="0" indent="0" algn="ctr">
               <a:buNone/>
             </a:pPr>
             <a:r>
@@ -8618,6 +8728,13 @@
             <a:prstDash val="solid"/>
           </a:ln>
         </p:spPr>
+        <p:txBody>
+          <a:bodyPr/>
+          <a:lstStyle/>
+          <a:p>
+            <a:endParaRPr lang="en-US"/>
+          </a:p>
+        </p:txBody>
       </p:sp>
       <p:sp>
         <p:nvSpPr>
@@ -8642,7 +8759,7 @@
           </a:bodyPr>
           <a:lstStyle/>
           <a:p>
-            <a:pPr algn="ctr" indent="0" marL="0">
+            <a:pPr marL="0" indent="0" algn="ctr">
               <a:buNone/>
             </a:pPr>
             <a:r>
@@ -8662,14 +8779,14 @@
       </p:sp>
       <p:pic>
         <p:nvPicPr>
-          <p:cNvPr id="8" name="Image 0" descr="/mnt/data/week8_random_signals/assets/ensemble_realizations.png">    </p:cNvPr>
+          <p:cNvPr id="8" name="Image 0" descr="/mnt/data/week8_random_signals/assets/ensemble_realizations.png"/>
           <p:cNvPicPr>
             <a:picLocks noChangeAspect="1"/>
           </p:cNvPicPr>
           <p:nvPr/>
         </p:nvPicPr>
         <p:blipFill>
-          <a:blip r:embed="rId1"/>
+          <a:blip r:embed="rId3"/>
           <a:stretch>
             <a:fillRect/>
           </a:stretch>
@@ -8710,6 +8827,13 @@
             <a:prstDash val="solid"/>
           </a:ln>
         </p:spPr>
+        <p:txBody>
+          <a:bodyPr/>
+          <a:lstStyle/>
+          <a:p>
+            <a:endParaRPr lang="en-US"/>
+          </a:p>
+        </p:txBody>
       </p:sp>
       <p:sp>
         <p:nvSpPr>
@@ -8735,6 +8859,13 @@
             <a:prstDash val="solid"/>
           </a:ln>
         </p:spPr>
+        <p:txBody>
+          <a:bodyPr/>
+          <a:lstStyle/>
+          <a:p>
+            <a:endParaRPr lang="en-US"/>
+          </a:p>
+        </p:txBody>
       </p:sp>
       <p:sp>
         <p:nvSpPr>
@@ -8757,7 +8888,7 @@
           <a:bodyPr wrap="square" lIns="0" tIns="0" rIns="0" bIns="0" rtlCol="0" anchor="ctr"/>
           <a:lstStyle/>
           <a:p>
-            <a:pPr indent="0" marL="0">
+            <a:pPr marL="0" indent="0">
               <a:buNone/>
             </a:pPr>
             <a:r>
@@ -8794,11 +8925,11 @@
         </p:spPr>
         <p:txBody>
           <a:bodyPr wrap="square" lIns="0" tIns="0" rIns="0" bIns="0" rtlCol="0" anchor="t">
-            <a:normAutofit/>
+            <a:normAutofit fontScale="92500" lnSpcReduction="10000"/>
           </a:bodyPr>
           <a:lstStyle/>
           <a:p>
-            <a:pPr indent="0" marL="0">
+            <a:pPr marL="0" indent="0">
               <a:buNone/>
             </a:pPr>
             <a:r>
@@ -8842,6 +8973,13 @@
             <a:prstDash val="solid"/>
           </a:ln>
         </p:spPr>
+        <p:txBody>
+          <a:bodyPr/>
+          <a:lstStyle/>
+          <a:p>
+            <a:endParaRPr lang="en-US"/>
+          </a:p>
+        </p:txBody>
       </p:sp>
       <p:sp>
         <p:nvSpPr>
@@ -8867,6 +9005,13 @@
             <a:prstDash val="solid"/>
           </a:ln>
         </p:spPr>
+        <p:txBody>
+          <a:bodyPr/>
+          <a:lstStyle/>
+          <a:p>
+            <a:endParaRPr lang="en-US"/>
+          </a:p>
+        </p:txBody>
       </p:sp>
       <p:sp>
         <p:nvSpPr>
@@ -8889,7 +9034,7 @@
           <a:bodyPr wrap="square" lIns="0" tIns="0" rIns="0" bIns="0" rtlCol="0" anchor="ctr"/>
           <a:lstStyle/>
           <a:p>
-            <a:pPr indent="0" marL="0">
+            <a:pPr marL="0" indent="0">
               <a:buNone/>
             </a:pPr>
             <a:r>
@@ -8926,11 +9071,11 @@
         </p:spPr>
         <p:txBody>
           <a:bodyPr wrap="square" lIns="0" tIns="0" rIns="0" bIns="0" rtlCol="0" anchor="t">
-            <a:normAutofit/>
+            <a:normAutofit fontScale="92500" lnSpcReduction="10000"/>
           </a:bodyPr>
           <a:lstStyle/>
           <a:p>
-            <a:pPr indent="0" marL="0">
+            <a:pPr marL="0" indent="0">
               <a:buNone/>
             </a:pPr>
             <a:r>
@@ -8968,7 +9113,7 @@
           </a:prstGeom>
           <a:extLst>
             <a:ext uri="{C572A759-6A51-4108-AA02-DFA0A04FC94B}">
-              <ma14:wrappingTextBoxFlag xmlns:ma14="http://schemas.microsoft.com/office/mac/drawingml/2011/main" val="0"/>
+              <ma14:wrappingTextBoxFlag xmlns:ma14="http://schemas.microsoft.com/office/mac/drawingml/2011/main" xmlns="" val="0"/>
             </a:ext>
           </a:extLst>
         </p:spPr>
@@ -8989,7 +9134,7 @@
           <a:p>
             <a:pPr algn="r"/>
             <a:fld id="{F7021451-1387-4CA6-816F-3879F97B5CBC}" type="slidenum">
-              <a:rPr b="0" lang="en-US"/>
+              <a:rPr lang="en-US" b="0"/>
               <a:t>4</a:t>
             </a:fld>
             <a:endParaRPr lang="en-US"/>
@@ -9042,7 +9187,7 @@
           <a:bodyPr wrap="square" lIns="0" tIns="0" rIns="0" bIns="0" rtlCol="0" anchor="ctr"/>
           <a:lstStyle/>
           <a:p>
-            <a:pPr indent="0" marL="0">
+            <a:pPr marL="0" indent="0">
               <a:buNone/>
             </a:pPr>
             <a:r>
@@ -9081,7 +9226,7 @@
           <a:bodyPr wrap="square" lIns="0" tIns="0" rIns="0" bIns="0" rtlCol="0" anchor="ctr"/>
           <a:lstStyle/>
           <a:p>
-            <a:pPr indent="0" marL="0">
+            <a:pPr marL="0" indent="0">
               <a:buNone/>
             </a:pPr>
             <a:r>
@@ -9123,6 +9268,13 @@
             <a:prstDash val="solid"/>
           </a:ln>
         </p:spPr>
+        <p:txBody>
+          <a:bodyPr/>
+          <a:lstStyle/>
+          <a:p>
+            <a:endParaRPr lang="en-US"/>
+          </a:p>
+        </p:txBody>
       </p:sp>
       <p:sp>
         <p:nvSpPr>
@@ -9147,7 +9299,7 @@
           </a:bodyPr>
           <a:lstStyle/>
           <a:p>
-            <a:pPr algn="ctr" indent="0" marL="0">
+            <a:pPr marL="0" indent="0" algn="ctr">
               <a:buNone/>
             </a:pPr>
             <a:r>
@@ -9189,6 +9341,13 @@
             <a:prstDash val="solid"/>
           </a:ln>
         </p:spPr>
+        <p:txBody>
+          <a:bodyPr/>
+          <a:lstStyle/>
+          <a:p>
+            <a:endParaRPr lang="en-US"/>
+          </a:p>
+        </p:txBody>
       </p:sp>
       <p:sp>
         <p:nvSpPr>
@@ -9213,7 +9372,7 @@
           </a:bodyPr>
           <a:lstStyle/>
           <a:p>
-            <a:pPr algn="ctr" indent="0" marL="0">
+            <a:pPr marL="0" indent="0" algn="ctr">
               <a:buNone/>
             </a:pPr>
             <a:r>
@@ -9335,6 +9494,13 @@
             <a:prstDash val="solid"/>
           </a:ln>
         </p:spPr>
+        <p:txBody>
+          <a:bodyPr/>
+          <a:lstStyle/>
+          <a:p>
+            <a:endParaRPr lang="en-US"/>
+          </a:p>
+        </p:txBody>
       </p:sp>
       <p:sp>
         <p:nvSpPr>
@@ -9360,6 +9526,13 @@
             <a:prstDash val="solid"/>
           </a:ln>
         </p:spPr>
+        <p:txBody>
+          <a:bodyPr/>
+          <a:lstStyle/>
+          <a:p>
+            <a:endParaRPr lang="en-US"/>
+          </a:p>
+        </p:txBody>
       </p:sp>
       <p:sp>
         <p:nvSpPr>
@@ -9382,7 +9555,7 @@
           <a:bodyPr wrap="square" lIns="0" tIns="0" rIns="0" bIns="0" rtlCol="0" anchor="ctr"/>
           <a:lstStyle/>
           <a:p>
-            <a:pPr indent="0" marL="0">
+            <a:pPr marL="0" indent="0">
               <a:buNone/>
             </a:pPr>
             <a:r>
@@ -9423,7 +9596,7 @@
           </a:bodyPr>
           <a:lstStyle/>
           <a:p>
-            <a:pPr indent="0" marL="0">
+            <a:pPr marL="0" indent="0">
               <a:buNone/>
             </a:pPr>
             <a:r>
@@ -9461,7 +9634,7 @@
           </a:prstGeom>
           <a:extLst>
             <a:ext uri="{C572A759-6A51-4108-AA02-DFA0A04FC94B}">
-              <ma14:wrappingTextBoxFlag xmlns:ma14="http://schemas.microsoft.com/office/mac/drawingml/2011/main" val="0"/>
+              <ma14:wrappingTextBoxFlag xmlns:ma14="http://schemas.microsoft.com/office/mac/drawingml/2011/main" xmlns="" val="0"/>
             </a:ext>
           </a:extLst>
         </p:spPr>
@@ -9482,7 +9655,7 @@
           <a:p>
             <a:pPr algn="r"/>
             <a:fld id="{F7021451-1387-4CA6-816F-3879F97B5CBC}" type="slidenum">
-              <a:rPr b="0" lang="en-US"/>
+              <a:rPr lang="en-US" b="0"/>
               <a:t>5</a:t>
             </a:fld>
             <a:endParaRPr lang="en-US"/>
@@ -9505,6 +9678,7 @@
         <a:solidFill>
           <a:srgbClr val="17324D"/>
         </a:solidFill>
+        <a:effectLst/>
       </p:bgPr>
     </p:bg>
     <p:spTree>
@@ -9542,7 +9716,7 @@
           <a:bodyPr wrap="square" lIns="0" tIns="0" rIns="0" bIns="0" rtlCol="0" anchor="ctr"/>
           <a:lstStyle/>
           <a:p>
-            <a:pPr indent="0" marL="0">
+            <a:pPr marL="0" indent="0">
               <a:buNone/>
             </a:pPr>
             <a:r>
@@ -9581,7 +9755,7 @@
           <a:bodyPr wrap="square" lIns="0" tIns="0" rIns="0" bIns="0" rtlCol="0" anchor="ctr"/>
           <a:lstStyle/>
           <a:p>
-            <a:pPr indent="0" marL="0">
+            <a:pPr marL="0" indent="0">
               <a:buNone/>
             </a:pPr>
             <a:r>
@@ -9620,7 +9794,7 @@
           <a:bodyPr wrap="square" lIns="0" tIns="0" rIns="0" bIns="0" rtlCol="0" anchor="ctr"/>
           <a:lstStyle/>
           <a:p>
-            <a:pPr indent="0" marL="0">
+            <a:pPr marL="0" indent="0">
               <a:buNone/>
             </a:pPr>
             <a:r>
@@ -9658,7 +9832,7 @@
           </a:prstGeom>
           <a:extLst>
             <a:ext uri="{C572A759-6A51-4108-AA02-DFA0A04FC94B}">
-              <ma14:wrappingTextBoxFlag xmlns:ma14="http://schemas.microsoft.com/office/mac/drawingml/2011/main" val="0"/>
+              <ma14:wrappingTextBoxFlag xmlns:ma14="http://schemas.microsoft.com/office/mac/drawingml/2011/main" xmlns="" val="0"/>
             </a:ext>
           </a:extLst>
         </p:spPr>
@@ -9679,7 +9853,7 @@
           <a:p>
             <a:pPr algn="r"/>
             <a:fld id="{F7021451-1387-4CA6-816F-3879F97B5CBC}" type="slidenum">
-              <a:rPr b="0" lang="en-US"/>
+              <a:rPr lang="en-US" b="0"/>
               <a:t>6</a:t>
             </a:fld>
             <a:endParaRPr lang="en-US"/>
@@ -9732,7 +9906,7 @@
           <a:bodyPr wrap="square" lIns="0" tIns="0" rIns="0" bIns="0" rtlCol="0" anchor="ctr"/>
           <a:lstStyle/>
           <a:p>
-            <a:pPr indent="0" marL="0">
+            <a:pPr marL="0" indent="0">
               <a:buNone/>
             </a:pPr>
             <a:r>
@@ -9771,7 +9945,7 @@
           <a:bodyPr wrap="square" lIns="0" tIns="0" rIns="0" bIns="0" rtlCol="0" anchor="ctr"/>
           <a:lstStyle/>
           <a:p>
-            <a:pPr indent="0" marL="0">
+            <a:pPr marL="0" indent="0">
               <a:buNone/>
             </a:pPr>
             <a:r>
@@ -9813,6 +9987,13 @@
             <a:prstDash val="solid"/>
           </a:ln>
         </p:spPr>
+        <p:txBody>
+          <a:bodyPr/>
+          <a:lstStyle/>
+          <a:p>
+            <a:endParaRPr lang="en-US"/>
+          </a:p>
+        </p:txBody>
       </p:sp>
       <p:sp>
         <p:nvSpPr>
@@ -9837,7 +10018,7 @@
           </a:bodyPr>
           <a:lstStyle/>
           <a:p>
-            <a:pPr algn="ctr" indent="0" marL="0">
+            <a:pPr marL="0" indent="0" algn="ctr">
               <a:buNone/>
             </a:pPr>
             <a:r>
@@ -9959,6 +10140,13 @@
             <a:prstDash val="solid"/>
           </a:ln>
         </p:spPr>
+        <p:txBody>
+          <a:bodyPr/>
+          <a:lstStyle/>
+          <a:p>
+            <a:endParaRPr lang="en-US"/>
+          </a:p>
+        </p:txBody>
       </p:sp>
       <p:sp>
         <p:nvSpPr>
@@ -9984,6 +10172,13 @@
             <a:prstDash val="solid"/>
           </a:ln>
         </p:spPr>
+        <p:txBody>
+          <a:bodyPr/>
+          <a:lstStyle/>
+          <a:p>
+            <a:endParaRPr lang="en-US"/>
+          </a:p>
+        </p:txBody>
       </p:sp>
       <p:sp>
         <p:nvSpPr>
@@ -10006,7 +10201,7 @@
           <a:bodyPr wrap="square" lIns="0" tIns="0" rIns="0" bIns="0" rtlCol="0" anchor="ctr"/>
           <a:lstStyle/>
           <a:p>
-            <a:pPr indent="0" marL="0">
+            <a:pPr marL="0" indent="0">
               <a:buNone/>
             </a:pPr>
             <a:r>
@@ -10047,7 +10242,7 @@
           </a:bodyPr>
           <a:lstStyle/>
           <a:p>
-            <a:pPr indent="0" marL="0">
+            <a:pPr marL="0" indent="0">
               <a:buNone/>
             </a:pPr>
             <a:r>
@@ -10091,6 +10286,13 @@
             <a:prstDash val="solid"/>
           </a:ln>
         </p:spPr>
+        <p:txBody>
+          <a:bodyPr/>
+          <a:lstStyle/>
+          <a:p>
+            <a:endParaRPr lang="en-US"/>
+          </a:p>
+        </p:txBody>
       </p:sp>
       <p:sp>
         <p:nvSpPr>
@@ -10116,6 +10318,13 @@
             <a:prstDash val="solid"/>
           </a:ln>
         </p:spPr>
+        <p:txBody>
+          <a:bodyPr/>
+          <a:lstStyle/>
+          <a:p>
+            <a:endParaRPr lang="en-US"/>
+          </a:p>
+        </p:txBody>
       </p:sp>
       <p:sp>
         <p:nvSpPr>
@@ -10138,7 +10347,7 @@
           <a:bodyPr wrap="square" lIns="0" tIns="0" rIns="0" bIns="0" rtlCol="0" anchor="ctr"/>
           <a:lstStyle/>
           <a:p>
-            <a:pPr indent="0" marL="0">
+            <a:pPr marL="0" indent="0">
               <a:buNone/>
             </a:pPr>
             <a:r>
@@ -10179,7 +10388,7 @@
           </a:bodyPr>
           <a:lstStyle/>
           <a:p>
-            <a:pPr indent="0" marL="0">
+            <a:pPr marL="0" indent="0">
               <a:buNone/>
             </a:pPr>
             <a:r>
@@ -10217,7 +10426,7 @@
           </a:prstGeom>
           <a:extLst>
             <a:ext uri="{C572A759-6A51-4108-AA02-DFA0A04FC94B}">
-              <ma14:wrappingTextBoxFlag xmlns:ma14="http://schemas.microsoft.com/office/mac/drawingml/2011/main" val="0"/>
+              <ma14:wrappingTextBoxFlag xmlns:ma14="http://schemas.microsoft.com/office/mac/drawingml/2011/main" xmlns="" val="0"/>
             </a:ext>
           </a:extLst>
         </p:spPr>
@@ -10238,7 +10447,7 @@
           <a:p>
             <a:pPr algn="r"/>
             <a:fld id="{F7021451-1387-4CA6-816F-3879F97B5CBC}" type="slidenum">
-              <a:rPr b="0" lang="en-US"/>
+              <a:rPr lang="en-US" b="0"/>
               <a:t>7</a:t>
             </a:fld>
             <a:endParaRPr lang="en-US"/>
@@ -10291,7 +10500,7 @@
           <a:bodyPr wrap="square" lIns="0" tIns="0" rIns="0" bIns="0" rtlCol="0" anchor="ctr"/>
           <a:lstStyle/>
           <a:p>
-            <a:pPr indent="0" marL="0">
+            <a:pPr marL="0" indent="0">
               <a:buNone/>
             </a:pPr>
             <a:r>
@@ -10330,7 +10539,7 @@
           <a:bodyPr wrap="square" lIns="0" tIns="0" rIns="0" bIns="0" rtlCol="0" anchor="ctr"/>
           <a:lstStyle/>
           <a:p>
-            <a:pPr indent="0" marL="0">
+            <a:pPr marL="0" indent="0">
               <a:buNone/>
             </a:pPr>
             <a:r>
@@ -10372,6 +10581,13 @@
             <a:prstDash val="solid"/>
           </a:ln>
         </p:spPr>
+        <p:txBody>
+          <a:bodyPr/>
+          <a:lstStyle/>
+          <a:p>
+            <a:endParaRPr lang="en-US"/>
+          </a:p>
+        </p:txBody>
       </p:sp>
       <p:sp>
         <p:nvSpPr>
@@ -10396,7 +10612,7 @@
           </a:bodyPr>
           <a:lstStyle/>
           <a:p>
-            <a:pPr algn="ctr" indent="0" marL="0">
+            <a:pPr marL="0" indent="0" algn="ctr">
               <a:buNone/>
             </a:pPr>
             <a:r>
@@ -10438,6 +10654,13 @@
             <a:prstDash val="solid"/>
           </a:ln>
         </p:spPr>
+        <p:txBody>
+          <a:bodyPr/>
+          <a:lstStyle/>
+          <a:p>
+            <a:endParaRPr lang="en-US"/>
+          </a:p>
+        </p:txBody>
       </p:sp>
       <p:sp>
         <p:nvSpPr>
@@ -10462,7 +10685,7 @@
           </a:bodyPr>
           <a:lstStyle/>
           <a:p>
-            <a:pPr algn="ctr" indent="0" marL="0">
+            <a:pPr marL="0" indent="0" algn="ctr">
               <a:buNone/>
             </a:pPr>
             <a:r>
@@ -10578,14 +10801,14 @@
       </p:sp>
       <p:pic>
         <p:nvPicPr>
-          <p:cNvPr id="9" name="Image 0" descr="/mnt/data/week8_random_signals/assets/stationarity_examples.png">    </p:cNvPr>
+          <p:cNvPr id="9" name="Image 0" descr="/mnt/data/week8_random_signals/assets/stationarity_examples.png"/>
           <p:cNvPicPr>
             <a:picLocks noChangeAspect="1"/>
           </p:cNvPicPr>
           <p:nvPr/>
         </p:nvPicPr>
         <p:blipFill>
-          <a:blip r:embed="rId1"/>
+          <a:blip r:embed="rId3"/>
           <a:stretch>
             <a:fillRect/>
           </a:stretch>
@@ -10626,6 +10849,13 @@
             <a:prstDash val="solid"/>
           </a:ln>
         </p:spPr>
+        <p:txBody>
+          <a:bodyPr/>
+          <a:lstStyle/>
+          <a:p>
+            <a:endParaRPr lang="en-US"/>
+          </a:p>
+        </p:txBody>
       </p:sp>
       <p:sp>
         <p:nvSpPr>
@@ -10651,6 +10881,13 @@
             <a:prstDash val="solid"/>
           </a:ln>
         </p:spPr>
+        <p:txBody>
+          <a:bodyPr/>
+          <a:lstStyle/>
+          <a:p>
+            <a:endParaRPr lang="en-US"/>
+          </a:p>
+        </p:txBody>
       </p:sp>
       <p:sp>
         <p:nvSpPr>
@@ -10673,7 +10910,7 @@
           <a:bodyPr wrap="square" lIns="0" tIns="0" rIns="0" bIns="0" rtlCol="0" anchor="ctr"/>
           <a:lstStyle/>
           <a:p>
-            <a:pPr indent="0" marL="0">
+            <a:pPr marL="0" indent="0">
               <a:buNone/>
             </a:pPr>
             <a:r>
@@ -10710,11 +10947,11 @@
         </p:spPr>
         <p:txBody>
           <a:bodyPr wrap="square" lIns="0" tIns="0" rIns="0" bIns="0" rtlCol="0" anchor="t">
-            <a:normAutofit/>
+            <a:normAutofit fontScale="62500" lnSpcReduction="20000"/>
           </a:bodyPr>
           <a:lstStyle/>
           <a:p>
-            <a:pPr indent="0" marL="0">
+            <a:pPr marL="0" indent="0">
               <a:buNone/>
             </a:pPr>
             <a:r>
@@ -10752,7 +10989,7 @@
           </a:prstGeom>
           <a:extLst>
             <a:ext uri="{C572A759-6A51-4108-AA02-DFA0A04FC94B}">
-              <ma14:wrappingTextBoxFlag xmlns:ma14="http://schemas.microsoft.com/office/mac/drawingml/2011/main" val="0"/>
+              <ma14:wrappingTextBoxFlag xmlns:ma14="http://schemas.microsoft.com/office/mac/drawingml/2011/main" xmlns="" val="0"/>
             </a:ext>
           </a:extLst>
         </p:spPr>
@@ -10773,7 +11010,7 @@
           <a:p>
             <a:pPr algn="r"/>
             <a:fld id="{F7021451-1387-4CA6-816F-3879F97B5CBC}" type="slidenum">
-              <a:rPr b="0" lang="en-US"/>
+              <a:rPr lang="en-US" b="0"/>
               <a:t>8</a:t>
             </a:fld>
             <a:endParaRPr lang="en-US"/>
@@ -10829,6 +11066,13 @@
             <a:prstDash val="solid"/>
           </a:ln>
         </p:spPr>
+        <p:txBody>
+          <a:bodyPr/>
+          <a:lstStyle/>
+          <a:p>
+            <a:endParaRPr lang="en-US"/>
+          </a:p>
+        </p:txBody>
       </p:sp>
       <p:sp>
         <p:nvSpPr>
@@ -10851,7 +11095,7 @@
           <a:bodyPr wrap="square" lIns="0" tIns="0" rIns="0" bIns="0" rtlCol="0" anchor="ctr"/>
           <a:lstStyle/>
           <a:p>
-            <a:pPr indent="0" marL="0">
+            <a:pPr marL="0" indent="0">
               <a:buNone/>
             </a:pPr>
             <a:r>
@@ -10892,7 +11136,7 @@
           </a:bodyPr>
           <a:lstStyle/>
           <a:p>
-            <a:pPr indent="0" marL="0">
+            <a:pPr marL="0" indent="0">
               <a:buNone/>
             </a:pPr>
             <a:r>
@@ -10931,7 +11175,7 @@
           <a:bodyPr wrap="square" lIns="0" tIns="0" rIns="0" bIns="0" rtlCol="0" anchor="ctr"/>
           <a:lstStyle/>
           <a:p>
-            <a:pPr indent="0" marL="0">
+            <a:pPr marL="0" indent="0">
               <a:buNone/>
             </a:pPr>
             <a:r>
@@ -10972,7 +11216,7 @@
           </a:bodyPr>
           <a:lstStyle/>
           <a:p>
-            <a:pPr indent="0" marL="0">
+            <a:pPr marL="0" indent="0">
               <a:buNone/>
             </a:pPr>
             <a:r>
@@ -11010,7 +11254,7 @@
           </a:prstGeom>
           <a:extLst>
             <a:ext uri="{C572A759-6A51-4108-AA02-DFA0A04FC94B}">
-              <ma14:wrappingTextBoxFlag xmlns:ma14="http://schemas.microsoft.com/office/mac/drawingml/2011/main" val="0"/>
+              <ma14:wrappingTextBoxFlag xmlns:ma14="http://schemas.microsoft.com/office/mac/drawingml/2011/main" xmlns="" val="0"/>
             </a:ext>
           </a:extLst>
         </p:spPr>
@@ -11031,7 +11275,7 @@
           <a:p>
             <a:pPr algn="r"/>
             <a:fld id="{F7021451-1387-4CA6-816F-3879F97B5CBC}" type="slidenum">
-              <a:rPr b="0" lang="en-US"/>
+              <a:rPr lang="en-US" b="0"/>
               <a:t>9</a:t>
             </a:fld>
             <a:endParaRPr lang="en-US"/>
@@ -11339,4 +11583,319 @@
     </a:ext>
   </a:extLst>
 </a:theme>
+</file>
+
+<file path=ppt/theme/theme2.xml><?xml version="1.0" encoding="utf-8"?>
+<a:theme xmlns:a="http://schemas.openxmlformats.org/drawingml/2006/main" name="Office Theme">
+  <a:themeElements>
+    <a:clrScheme name="Office">
+      <a:dk1>
+        <a:sysClr val="windowText" lastClr="000000"/>
+      </a:dk1>
+      <a:lt1>
+        <a:sysClr val="window" lastClr="FFFFFF"/>
+      </a:lt1>
+      <a:dk2>
+        <a:srgbClr val="0E2841"/>
+      </a:dk2>
+      <a:lt2>
+        <a:srgbClr val="E8E8E8"/>
+      </a:lt2>
+      <a:accent1>
+        <a:srgbClr val="156082"/>
+      </a:accent1>
+      <a:accent2>
+        <a:srgbClr val="E97132"/>
+      </a:accent2>
+      <a:accent3>
+        <a:srgbClr val="196B24"/>
+      </a:accent3>
+      <a:accent4>
+        <a:srgbClr val="0F9ED5"/>
+      </a:accent4>
+      <a:accent5>
+        <a:srgbClr val="A02B93"/>
+      </a:accent5>
+      <a:accent6>
+        <a:srgbClr val="4EA72E"/>
+      </a:accent6>
+      <a:hlink>
+        <a:srgbClr val="467886"/>
+      </a:hlink>
+      <a:folHlink>
+        <a:srgbClr val="96607D"/>
+      </a:folHlink>
+    </a:clrScheme>
+    <a:fontScheme name="Office">
+      <a:majorFont>
+        <a:latin typeface="Aptos Display" panose="02110004020202020204"/>
+        <a:ea typeface=""/>
+        <a:cs typeface=""/>
+        <a:font script="Jpan" typeface="游ゴシック Light"/>
+        <a:font script="Hang" typeface="맑은 고딕"/>
+        <a:font script="Hans" typeface="等线 Light"/>
+        <a:font script="Hant" typeface="新細明體"/>
+        <a:font script="Arab" typeface="Times New Roman"/>
+        <a:font script="Hebr" typeface="Times New Roman"/>
+        <a:font script="Thai" typeface="Angsana New"/>
+        <a:font script="Ethi" typeface="Nyala"/>
+        <a:font script="Beng" typeface="Vrinda"/>
+        <a:font script="Gujr" typeface="Shruti"/>
+        <a:font script="Khmr" typeface="MoolBoran"/>
+        <a:font script="Knda" typeface="Tunga"/>
+        <a:font script="Guru" typeface="Raavi"/>
+        <a:font script="Cans" typeface="Euphemia"/>
+        <a:font script="Cher" typeface="Plantagenet Cherokee"/>
+        <a:font script="Yiii" typeface="Microsoft Yi Baiti"/>
+        <a:font script="Tibt" typeface="Microsoft Himalaya"/>
+        <a:font script="Thaa" typeface="MV Boli"/>
+        <a:font script="Deva" typeface="Mangal"/>
+        <a:font script="Telu" typeface="Gautami"/>
+        <a:font script="Taml" typeface="Latha"/>
+        <a:font script="Syrc" typeface="Estrangelo Edessa"/>
+        <a:font script="Orya" typeface="Kalinga"/>
+        <a:font script="Mlym" typeface="Kartika"/>
+        <a:font script="Laoo" typeface="DokChampa"/>
+        <a:font script="Sinh" typeface="Iskoola Pota"/>
+        <a:font script="Mong" typeface="Mongolian Baiti"/>
+        <a:font script="Viet" typeface="Times New Roman"/>
+        <a:font script="Uigh" typeface="Microsoft Uighur"/>
+        <a:font script="Geor" typeface="Sylfaen"/>
+        <a:font script="Armn" typeface="Arial"/>
+        <a:font script="Bugi" typeface="Leelawadee UI"/>
+        <a:font script="Bopo" typeface="Microsoft JhengHei"/>
+        <a:font script="Java" typeface="Javanese Text"/>
+        <a:font script="Lisu" typeface="Segoe UI"/>
+        <a:font script="Mymr" typeface="Myanmar Text"/>
+        <a:font script="Nkoo" typeface="Ebrima"/>
+        <a:font script="Olck" typeface="Nirmala UI"/>
+        <a:font script="Osma" typeface="Ebrima"/>
+        <a:font script="Phag" typeface="Phagspa"/>
+        <a:font script="Syrn" typeface="Estrangelo Edessa"/>
+        <a:font script="Syrj" typeface="Estrangelo Edessa"/>
+        <a:font script="Syre" typeface="Estrangelo Edessa"/>
+        <a:font script="Sora" typeface="Nirmala UI"/>
+        <a:font script="Tale" typeface="Microsoft Tai Le"/>
+        <a:font script="Talu" typeface="Microsoft New Tai Lue"/>
+        <a:font script="Tfng" typeface="Ebrima"/>
+      </a:majorFont>
+      <a:minorFont>
+        <a:latin typeface="Aptos" panose="02110004020202020204"/>
+        <a:ea typeface=""/>
+        <a:cs typeface=""/>
+        <a:font script="Jpan" typeface="游ゴシック"/>
+        <a:font script="Hang" typeface="맑은 고딕"/>
+        <a:font script="Hans" typeface="等线"/>
+        <a:font script="Hant" typeface="新細明體"/>
+        <a:font script="Arab" typeface="Arial"/>
+        <a:font script="Hebr" typeface="Arial"/>
+        <a:font script="Thai" typeface="Cordia New"/>
+        <a:font script="Ethi" typeface="Nyala"/>
+        <a:font script="Beng" typeface="Vrinda"/>
+        <a:font script="Gujr" typeface="Shruti"/>
+        <a:font script="Khmr" typeface="DaunPenh"/>
+        <a:font script="Knda" typeface="Tunga"/>
+        <a:font script="Guru" typeface="Raavi"/>
+        <a:font script="Cans" typeface="Euphemia"/>
+        <a:font script="Cher" typeface="Plantagenet Cherokee"/>
+        <a:font script="Yiii" typeface="Microsoft Yi Baiti"/>
+        <a:font script="Tibt" typeface="Microsoft Himalaya"/>
+        <a:font script="Thaa" typeface="MV Boli"/>
+        <a:font script="Deva" typeface="Mangal"/>
+        <a:font script="Telu" typeface="Gautami"/>
+        <a:font script="Taml" typeface="Latha"/>
+        <a:font script="Syrc" typeface="Estrangelo Edessa"/>
+        <a:font script="Orya" typeface="Kalinga"/>
+        <a:font script="Mlym" typeface="Kartika"/>
+        <a:font script="Laoo" typeface="DokChampa"/>
+        <a:font script="Sinh" typeface="Iskoola Pota"/>
+        <a:font script="Mong" typeface="Mongolian Baiti"/>
+        <a:font script="Viet" typeface="Arial"/>
+        <a:font script="Uigh" typeface="Microsoft Uighur"/>
+        <a:font script="Geor" typeface="Sylfaen"/>
+        <a:font script="Armn" typeface="Arial"/>
+        <a:font script="Bugi" typeface="Leelawadee UI"/>
+        <a:font script="Bopo" typeface="Microsoft JhengHei"/>
+        <a:font script="Java" typeface="Javanese Text"/>
+        <a:font script="Lisu" typeface="Segoe UI"/>
+        <a:font script="Mymr" typeface="Myanmar Text"/>
+        <a:font script="Nkoo" typeface="Ebrima"/>
+        <a:font script="Olck" typeface="Nirmala UI"/>
+        <a:font script="Osma" typeface="Ebrima"/>
+        <a:font script="Phag" typeface="Phagspa"/>
+        <a:font script="Syrn" typeface="Estrangelo Edessa"/>
+        <a:font script="Syrj" typeface="Estrangelo Edessa"/>
+        <a:font script="Syre" typeface="Estrangelo Edessa"/>
+        <a:font script="Sora" typeface="Nirmala UI"/>
+        <a:font script="Tale" typeface="Microsoft Tai Le"/>
+        <a:font script="Talu" typeface="Microsoft New Tai Lue"/>
+        <a:font script="Tfng" typeface="Ebrima"/>
+      </a:minorFont>
+    </a:fontScheme>
+    <a:fmtScheme name="Office">
+      <a:fillStyleLst>
+        <a:solidFill>
+          <a:schemeClr val="phClr"/>
+        </a:solidFill>
+        <a:gradFill rotWithShape="1">
+          <a:gsLst>
+            <a:gs pos="0">
+              <a:schemeClr val="phClr">
+                <a:lumMod val="110000"/>
+                <a:satMod val="105000"/>
+                <a:tint val="67000"/>
+              </a:schemeClr>
+            </a:gs>
+            <a:gs pos="50000">
+              <a:schemeClr val="phClr">
+                <a:lumMod val="105000"/>
+                <a:satMod val="103000"/>
+                <a:tint val="73000"/>
+              </a:schemeClr>
+            </a:gs>
+            <a:gs pos="100000">
+              <a:schemeClr val="phClr">
+                <a:lumMod val="105000"/>
+                <a:satMod val="109000"/>
+                <a:tint val="81000"/>
+              </a:schemeClr>
+            </a:gs>
+          </a:gsLst>
+          <a:lin ang="5400000" scaled="0"/>
+        </a:gradFill>
+        <a:gradFill rotWithShape="1">
+          <a:gsLst>
+            <a:gs pos="0">
+              <a:schemeClr val="phClr">
+                <a:satMod val="103000"/>
+                <a:lumMod val="102000"/>
+                <a:tint val="94000"/>
+              </a:schemeClr>
+            </a:gs>
+            <a:gs pos="50000">
+              <a:schemeClr val="phClr">
+                <a:satMod val="110000"/>
+                <a:lumMod val="100000"/>
+                <a:shade val="100000"/>
+              </a:schemeClr>
+            </a:gs>
+            <a:gs pos="100000">
+              <a:schemeClr val="phClr">
+                <a:lumMod val="99000"/>
+                <a:satMod val="120000"/>
+                <a:shade val="78000"/>
+              </a:schemeClr>
+            </a:gs>
+          </a:gsLst>
+          <a:lin ang="5400000" scaled="0"/>
+        </a:gradFill>
+      </a:fillStyleLst>
+      <a:lnStyleLst>
+        <a:ln w="12700" cap="flat" cmpd="sng" algn="ctr">
+          <a:solidFill>
+            <a:schemeClr val="phClr"/>
+          </a:solidFill>
+          <a:prstDash val="solid"/>
+          <a:miter lim="800000"/>
+        </a:ln>
+        <a:ln w="19050" cap="flat" cmpd="sng" algn="ctr">
+          <a:solidFill>
+            <a:schemeClr val="phClr"/>
+          </a:solidFill>
+          <a:prstDash val="solid"/>
+          <a:miter lim="800000"/>
+        </a:ln>
+        <a:ln w="25400" cap="flat" cmpd="sng" algn="ctr">
+          <a:solidFill>
+            <a:schemeClr val="phClr"/>
+          </a:solidFill>
+          <a:prstDash val="solid"/>
+          <a:miter lim="800000"/>
+        </a:ln>
+      </a:lnStyleLst>
+      <a:effectStyleLst>
+        <a:effectStyle>
+          <a:effectLst/>
+        </a:effectStyle>
+        <a:effectStyle>
+          <a:effectLst/>
+        </a:effectStyle>
+        <a:effectStyle>
+          <a:effectLst>
+            <a:outerShdw blurRad="57150" dist="19050" dir="5400000" algn="ctr" rotWithShape="0">
+              <a:srgbClr val="000000">
+                <a:alpha val="63000"/>
+              </a:srgbClr>
+            </a:outerShdw>
+          </a:effectLst>
+        </a:effectStyle>
+      </a:effectStyleLst>
+      <a:bgFillStyleLst>
+        <a:solidFill>
+          <a:schemeClr val="phClr"/>
+        </a:solidFill>
+        <a:solidFill>
+          <a:schemeClr val="phClr">
+            <a:tint val="95000"/>
+            <a:satMod val="170000"/>
+          </a:schemeClr>
+        </a:solidFill>
+        <a:gradFill rotWithShape="1">
+          <a:gsLst>
+            <a:gs pos="0">
+              <a:schemeClr val="phClr">
+                <a:tint val="93000"/>
+                <a:satMod val="150000"/>
+                <a:shade val="98000"/>
+                <a:lumMod val="102000"/>
+              </a:schemeClr>
+            </a:gs>
+            <a:gs pos="50000">
+              <a:schemeClr val="phClr">
+                <a:tint val="98000"/>
+                <a:satMod val="130000"/>
+                <a:shade val="90000"/>
+                <a:lumMod val="103000"/>
+              </a:schemeClr>
+            </a:gs>
+            <a:gs pos="100000">
+              <a:schemeClr val="phClr">
+                <a:shade val="63000"/>
+                <a:satMod val="120000"/>
+              </a:schemeClr>
+            </a:gs>
+          </a:gsLst>
+          <a:lin ang="5400000" scaled="0"/>
+        </a:gradFill>
+      </a:bgFillStyleLst>
+    </a:fmtScheme>
+  </a:themeElements>
+  <a:objectDefaults>
+    <a:lnDef>
+      <a:spPr/>
+      <a:bodyPr/>
+      <a:lstStyle/>
+      <a:style>
+        <a:lnRef idx="2">
+          <a:schemeClr val="accent1"/>
+        </a:lnRef>
+        <a:fillRef idx="0">
+          <a:schemeClr val="accent1"/>
+        </a:fillRef>
+        <a:effectRef idx="1">
+          <a:schemeClr val="accent1"/>
+        </a:effectRef>
+        <a:fontRef idx="minor">
+          <a:schemeClr val="tx1"/>
+        </a:fontRef>
+      </a:style>
+    </a:lnDef>
+  </a:objectDefaults>
+  <a:extraClrSchemeLst/>
+  <a:extLst>
+    <a:ext uri="{05A4C25C-085E-4340-85A3-A5531E510DB2}">
+      <thm15:themeFamily xmlns:thm15="http://schemas.microsoft.com/office/thememl/2012/main" name="Office Theme" id="{2E142A2C-CD16-42D6-873A-C26D2A0506FA}" vid="{1BDDFF52-6CD6-40A5-AB3C-68EB2F1E4D0A}"/>
+    </a:ext>
+  </a:extLst>
+</a:theme>
 </file>
</xml_diff>